<commit_message>
Buat ulang slide Pertemuan 4 sesuai hasil eksperimen terbaru
- Sinkronkan slide desain (skenario, protokol validasi, metrik) dengan implementasi
- Tambah slide hasil 5-fold CV dan temuan kunci yang membaca angka langsung dari hasil_eksperimen/
- Tulis ulang slide penutup: deliverables, keterbatasan, dan rencana Pertemuan 5
- Ekspor tabel_feature_importance.csv dari pipeline

Co-Authored-By: Claude Opus 5 <noreply@anthropic.com>
</commit_message>
<xml_diff>
--- a/04_implemen_desain_eksperimen/PRE02_Pertemuan4_Implementasi_Desain_Eksperimen.pptx
+++ b/04_implemen_desain_eksperimen/PRE02_Pertemuan4_Implementasi_Desain_Eksperimen.pptx
@@ -13,6 +13,8 @@
     <p:sldId id="261" r:id="rId12"/>
     <p:sldId id="262" r:id="rId13"/>
     <p:sldId id="263" r:id="rId14"/>
+    <p:sldId id="264" r:id="rId15"/>
+    <p:sldId id="265" r:id="rId16"/>
   </p:sldIdLst>
   <p:sldSz cx="12191999" cy="6858000" type="screen4x3"/>
   <p:notesSz cx="6858000" cy="9144000"/>
@@ -3349,6 +3351,453 @@
 </p:sld>
 </file>
 
+<file path=ppt/slides/slide10.xml><?xml version="1.0" encoding="utf-8"?>
+<p:sld xmlns:a="http://schemas.openxmlformats.org/drawingml/2006/main" xmlns:p="http://schemas.openxmlformats.org/presentationml/2006/main" xmlns:r="http://schemas.openxmlformats.org/officeDocument/2006/relationships">
+  <p:cSld>
+    <p:bg>
+      <p:bgPr>
+        <a:solidFill>
+          <a:srgbClr val="1E4220"/>
+        </a:solidFill>
+        <a:effectLst/>
+      </p:bgPr>
+    </p:bg>
+    <p:spTree>
+      <p:nvGrpSpPr>
+        <p:cNvPr id="1" name=""/>
+        <p:cNvGrpSpPr/>
+        <p:nvPr/>
+      </p:nvGrpSpPr>
+      <p:grpSpPr/>
+      <p:sp>
+        <p:nvSpPr>
+          <p:cNvPr id="2" name="TextBox 1"/>
+          <p:cNvSpPr txBox="1"/>
+          <p:nvPr/>
+        </p:nvSpPr>
+        <p:spPr>
+          <a:xfrm>
+            <a:off x="731520" y="1097280"/>
+            <a:ext cx="7315200" cy="365760"/>
+          </a:xfrm>
+          <a:prstGeom prst="rect">
+            <a:avLst/>
+          </a:prstGeom>
+          <a:noFill/>
+        </p:spPr>
+        <p:txBody>
+          <a:bodyPr wrap="none">
+            <a:spAutoFit/>
+          </a:bodyPr>
+          <a:lstStyle/>
+          <a:p>
+            <a:pPr>
+              <a:defRPr sz="1300" b="1">
+                <a:solidFill>
+                  <a:srgbClr val="E8A33D"/>
+                </a:solidFill>
+                <a:latin typeface="Calibri"/>
+              </a:defRPr>
+            </a:pPr>
+            <a:r>
+              <a:t>STATUS &amp; ROADMAP KELANJUTAN</a:t>
+            </a:r>
+          </a:p>
+        </p:txBody>
+      </p:sp>
+      <p:sp>
+        <p:nvSpPr>
+          <p:cNvPr id="3" name="TextBox 2"/>
+          <p:cNvSpPr txBox="1"/>
+          <p:nvPr/>
+        </p:nvSpPr>
+        <p:spPr>
+          <a:xfrm>
+            <a:off x="731520" y="1554480"/>
+            <a:ext cx="10515600" cy="1097280"/>
+          </a:xfrm>
+          <a:prstGeom prst="rect">
+            <a:avLst/>
+          </a:prstGeom>
+          <a:noFill/>
+        </p:spPr>
+        <p:txBody>
+          <a:bodyPr wrap="square">
+            <a:spAutoFit/>
+          </a:bodyPr>
+          <a:lstStyle/>
+          <a:p>
+            <a:pPr>
+              <a:defRPr sz="2600" b="1">
+                <a:solidFill>
+                  <a:srgbClr val="FFFFFF"/>
+                </a:solidFill>
+                <a:latin typeface="Cambria"/>
+              </a:defRPr>
+            </a:pPr>
+            <a:r>
+              <a:t>Capaian Pertemuan 4:</a:t>
+            </a:r>
+            <a:br/>
+            <a:r>
+              <a:t>Desain Eksperimen Terimplementasi &amp; Arah Pertemuan 5</a:t>
+            </a:r>
+          </a:p>
+        </p:txBody>
+      </p:sp>
+      <p:sp>
+        <p:nvSpPr>
+          <p:cNvPr id="4" name="Rounded Rectangle 3"/>
+          <p:cNvSpPr/>
+          <p:nvPr/>
+        </p:nvSpPr>
+        <p:spPr>
+          <a:xfrm>
+            <a:off x="731520" y="3017520"/>
+            <a:ext cx="3383280" cy="2926080"/>
+          </a:xfrm>
+          <a:prstGeom prst="roundRect">
+            <a:avLst/>
+          </a:prstGeom>
+          <a:solidFill>
+            <a:srgbClr val="2C5F2D"/>
+          </a:solidFill>
+          <a:ln>
+            <a:noFill/>
+          </a:ln>
+        </p:spPr>
+        <p:style>
+          <a:lnRef idx="1">
+            <a:schemeClr val="accent1"/>
+          </a:lnRef>
+          <a:fillRef idx="3">
+            <a:schemeClr val="accent1"/>
+          </a:fillRef>
+          <a:effectRef idx="2">
+            <a:schemeClr val="accent1"/>
+          </a:effectRef>
+          <a:fontRef idx="minor">
+            <a:schemeClr val="lt1"/>
+          </a:fontRef>
+        </p:style>
+        <p:txBody>
+          <a:bodyPr rtlCol="0" anchor="ctr"/>
+          <a:lstStyle/>
+          <a:p>
+            <a:pPr algn="ctr"/>
+          </a:p>
+        </p:txBody>
+      </p:sp>
+      <p:sp>
+        <p:nvSpPr>
+          <p:cNvPr id="5" name="TextBox 4"/>
+          <p:cNvSpPr txBox="1"/>
+          <p:nvPr/>
+        </p:nvSpPr>
+        <p:spPr>
+          <a:xfrm>
+            <a:off x="1005840" y="3383280"/>
+            <a:ext cx="2834640" cy="548640"/>
+          </a:xfrm>
+          <a:prstGeom prst="rect">
+            <a:avLst/>
+          </a:prstGeom>
+          <a:noFill/>
+        </p:spPr>
+        <p:txBody>
+          <a:bodyPr wrap="square">
+            <a:spAutoFit/>
+          </a:bodyPr>
+          <a:lstStyle/>
+          <a:p>
+            <a:pPr>
+              <a:defRPr sz="1500" b="1">
+                <a:solidFill>
+                  <a:srgbClr val="E8A33D"/>
+                </a:solidFill>
+                <a:latin typeface="Cambria"/>
+              </a:defRPr>
+            </a:pPr>
+            <a:r>
+              <a:t>1. Deliverables</a:t>
+            </a:r>
+          </a:p>
+        </p:txBody>
+      </p:sp>
+      <p:sp>
+        <p:nvSpPr>
+          <p:cNvPr id="6" name="TextBox 5"/>
+          <p:cNvSpPr txBox="1"/>
+          <p:nvPr/>
+        </p:nvSpPr>
+        <p:spPr>
+          <a:xfrm>
+            <a:off x="1005840" y="4023360"/>
+            <a:ext cx="2834640" cy="1645920"/>
+          </a:xfrm>
+          <a:prstGeom prst="rect">
+            <a:avLst/>
+          </a:prstGeom>
+          <a:noFill/>
+        </p:spPr>
+        <p:txBody>
+          <a:bodyPr wrap="square">
+            <a:spAutoFit/>
+          </a:bodyPr>
+          <a:lstStyle/>
+          <a:p>
+            <a:pPr>
+              <a:defRPr sz="1200">
+                <a:solidFill>
+                  <a:srgbClr val="E4EFD8"/>
+                </a:solidFill>
+                <a:latin typeface="Calibri"/>
+              </a:defRPr>
+            </a:pPr>
+            <a:r>
+              <a:t>Flow &amp; 5 skenario eksperimen, experiment_pipeline.py (4 model + kalibrasi Platt/Isotonic, diverifikasi terhadap scikit-learn), dan draft Bab III Metodologi.</a:t>
+            </a:r>
+          </a:p>
+        </p:txBody>
+      </p:sp>
+      <p:sp>
+        <p:nvSpPr>
+          <p:cNvPr id="7" name="Rounded Rectangle 6"/>
+          <p:cNvSpPr/>
+          <p:nvPr/>
+        </p:nvSpPr>
+        <p:spPr>
+          <a:xfrm>
+            <a:off x="4389120" y="3017520"/>
+            <a:ext cx="3383280" cy="2926080"/>
+          </a:xfrm>
+          <a:prstGeom prst="roundRect">
+            <a:avLst/>
+          </a:prstGeom>
+          <a:solidFill>
+            <a:srgbClr val="2C5F2D"/>
+          </a:solidFill>
+          <a:ln>
+            <a:noFill/>
+          </a:ln>
+        </p:spPr>
+        <p:style>
+          <a:lnRef idx="1">
+            <a:schemeClr val="accent1"/>
+          </a:lnRef>
+          <a:fillRef idx="3">
+            <a:schemeClr val="accent1"/>
+          </a:fillRef>
+          <a:effectRef idx="2">
+            <a:schemeClr val="accent1"/>
+          </a:effectRef>
+          <a:fontRef idx="minor">
+            <a:schemeClr val="lt1"/>
+          </a:fontRef>
+        </p:style>
+        <p:txBody>
+          <a:bodyPr rtlCol="0" anchor="ctr"/>
+          <a:lstStyle/>
+          <a:p>
+            <a:pPr algn="ctr"/>
+          </a:p>
+        </p:txBody>
+      </p:sp>
+      <p:sp>
+        <p:nvSpPr>
+          <p:cNvPr id="8" name="TextBox 7"/>
+          <p:cNvSpPr txBox="1"/>
+          <p:nvPr/>
+        </p:nvSpPr>
+        <p:spPr>
+          <a:xfrm>
+            <a:off x="4663440" y="3383280"/>
+            <a:ext cx="2834640" cy="548640"/>
+          </a:xfrm>
+          <a:prstGeom prst="rect">
+            <a:avLst/>
+          </a:prstGeom>
+          <a:noFill/>
+        </p:spPr>
+        <p:txBody>
+          <a:bodyPr wrap="square">
+            <a:spAutoFit/>
+          </a:bodyPr>
+          <a:lstStyle/>
+          <a:p>
+            <a:pPr>
+              <a:defRPr sz="1500" b="1">
+                <a:solidFill>
+                  <a:srgbClr val="E8A33D"/>
+                </a:solidFill>
+                <a:latin typeface="Cambria"/>
+              </a:defRPr>
+            </a:pPr>
+            <a:r>
+              <a:t>2. Keterbatasan</a:t>
+            </a:r>
+          </a:p>
+        </p:txBody>
+      </p:sp>
+      <p:sp>
+        <p:nvSpPr>
+          <p:cNvPr id="9" name="TextBox 8"/>
+          <p:cNvSpPr txBox="1"/>
+          <p:nvPr/>
+        </p:nvSpPr>
+        <p:spPr>
+          <a:xfrm>
+            <a:off x="4663440" y="4023360"/>
+            <a:ext cx="2834640" cy="1645920"/>
+          </a:xfrm>
+          <a:prstGeom prst="rect">
+            <a:avLst/>
+          </a:prstGeom>
+          <a:noFill/>
+        </p:spPr>
+        <p:txBody>
+          <a:bodyPr wrap="square">
+            <a:spAutoFit/>
+          </a:bodyPr>
+          <a:lstStyle/>
+          <a:p>
+            <a:pPr>
+              <a:defRPr sz="1200">
+                <a:solidFill>
+                  <a:srgbClr val="E4EFD8"/>
+                </a:solidFill>
+                <a:latin typeface="Calibri"/>
+              </a:defRPr>
+            </a:pPr>
+            <a:r>
+              <a:t>N = 26 dan data empiris-simulatif: ROC-AUC ≈ 1.0 berarti kelas hampir terpisah sempurna, sehingga hasil belum dapat digeneralisasi.</a:t>
+            </a:r>
+          </a:p>
+        </p:txBody>
+      </p:sp>
+      <p:sp>
+        <p:nvSpPr>
+          <p:cNvPr id="10" name="Rounded Rectangle 9"/>
+          <p:cNvSpPr/>
+          <p:nvPr/>
+        </p:nvSpPr>
+        <p:spPr>
+          <a:xfrm>
+            <a:off x="8046720" y="3017520"/>
+            <a:ext cx="3383280" cy="2926080"/>
+          </a:xfrm>
+          <a:prstGeom prst="roundRect">
+            <a:avLst/>
+          </a:prstGeom>
+          <a:solidFill>
+            <a:srgbClr val="2C5F2D"/>
+          </a:solidFill>
+          <a:ln>
+            <a:noFill/>
+          </a:ln>
+        </p:spPr>
+        <p:style>
+          <a:lnRef idx="1">
+            <a:schemeClr val="accent1"/>
+          </a:lnRef>
+          <a:fillRef idx="3">
+            <a:schemeClr val="accent1"/>
+          </a:fillRef>
+          <a:effectRef idx="2">
+            <a:schemeClr val="accent1"/>
+          </a:effectRef>
+          <a:fontRef idx="minor">
+            <a:schemeClr val="lt1"/>
+          </a:fontRef>
+        </p:style>
+        <p:txBody>
+          <a:bodyPr rtlCol="0" anchor="ctr"/>
+          <a:lstStyle/>
+          <a:p>
+            <a:pPr algn="ctr"/>
+          </a:p>
+        </p:txBody>
+      </p:sp>
+      <p:sp>
+        <p:nvSpPr>
+          <p:cNvPr id="11" name="TextBox 10"/>
+          <p:cNvSpPr txBox="1"/>
+          <p:nvPr/>
+        </p:nvSpPr>
+        <p:spPr>
+          <a:xfrm>
+            <a:off x="8321040" y="3383280"/>
+            <a:ext cx="2834640" cy="548640"/>
+          </a:xfrm>
+          <a:prstGeom prst="rect">
+            <a:avLst/>
+          </a:prstGeom>
+          <a:noFill/>
+        </p:spPr>
+        <p:txBody>
+          <a:bodyPr wrap="square">
+            <a:spAutoFit/>
+          </a:bodyPr>
+          <a:lstStyle/>
+          <a:p>
+            <a:pPr>
+              <a:defRPr sz="1500" b="1">
+                <a:solidFill>
+                  <a:srgbClr val="E8A33D"/>
+                </a:solidFill>
+                <a:latin typeface="Cambria"/>
+              </a:defRPr>
+            </a:pPr>
+            <a:r>
+              <a:t>3. Pertemuan 5</a:t>
+            </a:r>
+          </a:p>
+        </p:txBody>
+      </p:sp>
+      <p:sp>
+        <p:nvSpPr>
+          <p:cNvPr id="12" name="TextBox 11"/>
+          <p:cNvSpPr txBox="1"/>
+          <p:nvPr/>
+        </p:nvSpPr>
+        <p:spPr>
+          <a:xfrm>
+            <a:off x="8321040" y="4023360"/>
+            <a:ext cx="2834640" cy="1645920"/>
+          </a:xfrm>
+          <a:prstGeom prst="rect">
+            <a:avLst/>
+          </a:prstGeom>
+          <a:noFill/>
+        </p:spPr>
+        <p:txBody>
+          <a:bodyPr wrap="square">
+            <a:spAutoFit/>
+          </a:bodyPr>
+          <a:lstStyle/>
+          <a:p>
+            <a:pPr>
+              <a:defRPr sz="1200">
+                <a:solidFill>
+                  <a:srgbClr val="E4EFD8"/>
+                </a:solidFill>
+                <a:latin typeface="Calibri"/>
+              </a:defRPr>
+            </a:pPr>
+            <a:r>
+              <a:t>Validasi pada data proyek riil yang lebih besar, kaji ulang hipotesis multi sumber daya terhadap fitur dominan, dan susun Bab IV.</a:t>
+            </a:r>
+          </a:p>
+        </p:txBody>
+      </p:sp>
+    </p:spTree>
+  </p:cSld>
+  <p:clrMapOvr>
+    <a:masterClrMapping/>
+  </p:clrMapOvr>
+</p:sld>
+</file>
+
 <file path=ppt/slides/slide2.xml><?xml version="1.0" encoding="utf-8"?>
 <p:sld xmlns:a="http://schemas.openxmlformats.org/drawingml/2006/main" xmlns:p="http://schemas.openxmlformats.org/presentationml/2006/main" xmlns:r="http://schemas.openxmlformats.org/officeDocument/2006/relationships">
   <p:cSld>
@@ -4835,7 +5284,7 @@
               </a:defRPr>
             </a:pPr>
             <a:r>
-              <a:t>Koreksi distorsi kurva probabilitas via Isotonic &amp; Platt Scaling.</a:t>
+              <a:t>Platt Scaling &amp; Isotonic Regression, dilatih pada inner 3-fold di dalam fold training (tanpa kebocoran data).</a:t>
             </a:r>
           </a:p>
         </p:txBody>
@@ -5105,7 +5554,7 @@
               </a:defRPr>
             </a:pPr>
             <a:r>
-              <a:t>Early Warning EWS</a:t>
+              <a:t>Threshold &amp; EWS</a:t>
             </a:r>
           </a:p>
         </p:txBody>
@@ -5141,7 +5590,7 @@
               </a:defRPr>
             </a:pPr>
             <a:r>
-              <a:t>Translasi probabilitas ke 3 zona mitigasi risiko bagi Project Manager.</a:t>
+              <a:t>Analisis ambang Youden J dan translasi probabilitas ke 3 zona mitigasi bagi Project Manager.</a:t>
             </a:r>
           </a:p>
         </p:txBody>
@@ -5528,7 +5977,7 @@
               </a:defRPr>
             </a:pPr>
             <a:r>
-              <a:t>Menghasilkan probabilitas terkalibrasi alami via fungsi sigmoid matematis. Berperan sebagai benchmark linear L2.</a:t>
+              <a:t>Probabilitas via fungsi sigmoid; regularisasi L2 (C = 1.0) diselesaikan hingga konvergen. Berperan sebagai benchmark linear.</a:t>
             </a:r>
           </a:p>
         </p:txBody>
@@ -5681,7 +6130,7 @@
               </a:defRPr>
             </a:pPr>
             <a:r>
-              <a:t>predict_proba Voting</a:t>
+              <a:t>predict_proba</a:t>
             </a:r>
           </a:p>
         </p:txBody>
@@ -5717,7 +6166,7 @@
               </a:defRPr>
             </a:pPr>
             <a:r>
-              <a:t>Menggabungkan 100 decision trees secara paralel. Mengukur frekuensi voting probabilitas dan mengekstraksi Feature Importance.</a:t>
+              <a:t>100 pohon (max_depth 3). Probabilitas = rata-rata proporsi kelas delay di daun seluruh pohon; menghasilkan Feature Importance MDI.</a:t>
             </a:r>
           </a:p>
         </p:txBody>
@@ -5906,7 +6355,7 @@
               </a:defRPr>
             </a:pPr>
             <a:r>
-              <a:t>Membangun pohon secara berurutan dengan minimisasi log-loss residual. Menawarkan daya pemisahan margin yang tinggi.</a:t>
+              <a:t>100 pohon regresi berurutan pada pseudo-residual log-loss (learning rate 0.05, max_depth 2, subsample 0.8).</a:t>
             </a:r>
           </a:p>
         </p:txBody>
@@ -6095,7 +6544,7 @@
               </a:defRPr>
             </a:pPr>
             <a:r>
-              <a:t>Arsitektur 2 lapis tersembunyi (16-8 neuron) dengan aktivasi ReLU dan output neuron sigmoid tunggal.</a:t>
+              <a:t>2 lapis tersembunyi (16-8 neuron, ReLU) dan output sigmoid; optimasi Adam (lr 0.01, 1000 iterasi, alpha 0.01).</a:t>
             </a:r>
           </a:p>
         </p:txBody>
@@ -6248,7 +6697,7 @@
               </a:defRPr>
             </a:pPr>
             <a:r>
-              <a:t>Isotonic / Platt Scaling</a:t>
+              <a:t>Platt / Isotonic</a:t>
             </a:r>
           </a:p>
         </p:txBody>
@@ -6284,7 +6733,7 @@
               </a:defRPr>
             </a:pPr>
             <a:r>
-              <a:t>Evaluasi Expected Calibration Error (ECE) dan Reliability Diagram guna menjamin akurasi probabilitas numerik.</a:t>
+              <a:t>Tiap model diuji Raw vs Platt vs Isotonic. Kombinasi dengan Brier Score terendah menjadi model rekomendasi.</a:t>
             </a:r>
           </a:p>
         </p:txBody>
@@ -6635,7 +7084,7 @@
               </a:defRPr>
             </a:pPr>
             <a:r>
-              <a:t>Mengingat N=26, Stratified K-Fold membagi data menjadi 5 lipatan dengan menjaga rasio 61.5% Delay : 38.5% On-Time di setiap iterasi pelatihan dan pengujian.</a:t>
+              <a:t>Mengingat N=26, Stratified K-Fold membagi data menjadi 5 lipatan dengan menjaga rasio 61.5% Delay : 38.5% On-Time. Hold-out 80:20 (21:5 task) dijalankan sebagai pembanding indikatif.</a:t>
             </a:r>
           </a:p>
         </p:txBody>
@@ -6788,7 +7237,7 @@
               </a:defRPr>
             </a:pPr>
             <a:r>
-              <a:t>Penskalaan fitur z-score (mean=0, std=1) dihitung HANYA dari data latih tiap fold, lalu diterapkan ke data uji. Mencegah fenomena data leakage.</a:t>
+              <a:t>Penskalaan z-score dan kalibrator dihitung HANYA dari data latih tiap fold (kalibrator via inner 3-fold), lalu diterapkan ke data uji. Mencegah data leakage.</a:t>
             </a:r>
           </a:p>
         </p:txBody>
@@ -6945,11 +7394,15 @@
             </a:r>
             <a:br/>
             <a:r>
-              <a:t>• Pembatasan max_depth (3-4) pada tree models.</a:t>
+              <a:t>• Pembatasan max_depth: 3 (RF) dan 2 (GB).</a:t>
             </a:r>
             <a:br/>
             <a:r>
-              <a:t>• Penalti L2 pada Logistic Regression &amp; MLP untuk kestabilan.</a:t>
+              <a:t>• Penalti L2 pada Logistic Regression &amp; MLP.</a:t>
+            </a:r>
+            <a:br/>
+            <a:r>
+              <a:t>• Implementasi diverifikasi terhadap scikit-learn.</a:t>
             </a:r>
           </a:p>
         </p:txBody>
@@ -7277,7 +7730,7 @@
             </a:r>
             <a:br/>
             <a:r>
-              <a:t>Mengukur kesenjangan absolut antara confidence level prediksi dan empirical accuracy dalam interval bin.</a:t>
+              <a:t>Mengukur kesenjangan absolut antara confidence level prediksi dan empirical accuracy dalam 5 bin interval (N = 26).</a:t>
             </a:r>
             <a:br/>
             <a:br/>
@@ -7425,7 +7878,7 @@
             </a:r>
             <a:br/>
             <a:r>
-              <a:t>Evaluasi performa klasifikasi operasional pada titik threshold rekomendasi.</a:t>
+              <a:t>Evaluasi performa klasifikasi pada threshold 0.5, dilengkapi ambang optimal Youden J.</a:t>
             </a:r>
           </a:p>
         </p:txBody>
@@ -8227,14 +8680,6 @@
 <file path=ppt/slides/slide8.xml><?xml version="1.0" encoding="utf-8"?>
 <p:sld xmlns:a="http://schemas.openxmlformats.org/drawingml/2006/main" xmlns:p="http://schemas.openxmlformats.org/presentationml/2006/main" xmlns:r="http://schemas.openxmlformats.org/officeDocument/2006/relationships">
   <p:cSld>
-    <p:bg>
-      <p:bgPr>
-        <a:solidFill>
-          <a:srgbClr val="1E4220"/>
-        </a:solidFill>
-        <a:effectLst/>
-      </p:bgPr>
-    </p:bg>
     <p:spTree>
       <p:nvGrpSpPr>
         <p:cNvPr id="1" name=""/>
@@ -8250,22 +8695,22 @@
         </p:nvSpPr>
         <p:spPr>
           <a:xfrm>
-            <a:off x="731520" y="1097280"/>
-            <a:ext cx="7315200" cy="365760"/>
-          </a:xfrm>
-          <a:prstGeom prst="rect">
-            <a:avLst/>
-          </a:prstGeom>
-          <a:noFill/>
-        </p:spPr>
-        <p:txBody>
-          <a:bodyPr wrap="none">
-            <a:spAutoFit/>
-          </a:bodyPr>
-          <a:lstStyle/>
-          <a:p>
-            <a:pPr>
-              <a:defRPr sz="1300" b="1">
+            <a:off x="731520" y="411480"/>
+            <a:ext cx="10058400" cy="320040"/>
+          </a:xfrm>
+          <a:prstGeom prst="rect">
+            <a:avLst/>
+          </a:prstGeom>
+          <a:noFill/>
+        </p:spPr>
+        <p:txBody>
+          <a:bodyPr wrap="square" lIns="0" tIns="0" rIns="0" bIns="0">
+            <a:spAutoFit/>
+          </a:bodyPr>
+          <a:lstStyle/>
+          <a:p>
+            <a:pPr>
+              <a:defRPr sz="1000" b="1">
                 <a:solidFill>
                   <a:srgbClr val="E8A33D"/>
                 </a:solidFill>
@@ -8273,7 +8718,7 @@
               </a:defRPr>
             </a:pPr>
             <a:r>
-              <a:t>STATUS &amp; ROADMAP KELANJUTAN</a:t>
+              <a:t>HASIL EKSPERIMEN</a:t>
             </a:r>
           </a:p>
         </p:txBody>
@@ -8286,8 +8731,2393 @@
         </p:nvSpPr>
         <p:spPr>
           <a:xfrm>
-            <a:off x="731520" y="1554480"/>
-            <a:ext cx="10515600" cy="1097280"/>
+            <a:off x="731520" y="685800"/>
+            <a:ext cx="10515600" cy="594360"/>
+          </a:xfrm>
+          <a:prstGeom prst="rect">
+            <a:avLst/>
+          </a:prstGeom>
+          <a:noFill/>
+        </p:spPr>
+        <p:txBody>
+          <a:bodyPr wrap="square" lIns="0" tIns="0" rIns="0" bIns="0">
+            <a:spAutoFit/>
+          </a:bodyPr>
+          <a:lstStyle/>
+          <a:p>
+            <a:pPr>
+              <a:defRPr sz="2200" b="1">
+                <a:solidFill>
+                  <a:srgbClr val="1E4220"/>
+                </a:solidFill>
+                <a:latin typeface="Cambria"/>
+              </a:defRPr>
+            </a:pPr>
+            <a:r>
+              <a:t>Kinerja 4 Algoritma × 3 Metode Kalibrasi (Stratified 5-Fold CV)</a:t>
+            </a:r>
+          </a:p>
+        </p:txBody>
+      </p:sp>
+      <p:sp>
+        <p:nvSpPr>
+          <p:cNvPr id="4" name="TextBox 3"/>
+          <p:cNvSpPr txBox="1"/>
+          <p:nvPr/>
+        </p:nvSpPr>
+        <p:spPr>
+          <a:xfrm>
+            <a:off x="731520" y="1234440"/>
+            <a:ext cx="10515600" cy="320040"/>
+          </a:xfrm>
+          <a:prstGeom prst="rect">
+            <a:avLst/>
+          </a:prstGeom>
+          <a:noFill/>
+        </p:spPr>
+        <p:txBody>
+          <a:bodyPr wrap="square" lIns="0" tIns="0" rIns="0" bIns="0">
+            <a:spAutoFit/>
+          </a:bodyPr>
+          <a:lstStyle/>
+          <a:p>
+            <a:pPr>
+              <a:defRPr sz="1150">
+                <a:solidFill>
+                  <a:srgbClr val="5B6B5C"/>
+                </a:solidFill>
+                <a:latin typeface="Calibri"/>
+              </a:defRPr>
+            </a:pPr>
+            <a:r>
+              <a:t>Baris tebal = model rekomendasi (Brier Score terendah): MLP Neural Network (tanpa kalibrasi).</a:t>
+            </a:r>
+          </a:p>
+        </p:txBody>
+      </p:sp>
+      <p:sp>
+        <p:nvSpPr>
+          <p:cNvPr id="5" name="TextBox 4"/>
+          <p:cNvSpPr txBox="1"/>
+          <p:nvPr/>
+        </p:nvSpPr>
+        <p:spPr>
+          <a:xfrm>
+            <a:off x="731520" y="6492240"/>
+            <a:ext cx="7315200" cy="274320"/>
+          </a:xfrm>
+          <a:prstGeom prst="rect">
+            <a:avLst/>
+          </a:prstGeom>
+          <a:noFill/>
+        </p:spPr>
+        <p:txBody>
+          <a:bodyPr wrap="square" lIns="0" tIns="0" rIns="0" bIns="0">
+            <a:spAutoFit/>
+          </a:bodyPr>
+          <a:lstStyle/>
+          <a:p>
+            <a:pPr>
+              <a:defRPr sz="900">
+                <a:solidFill>
+                  <a:srgbClr val="5B6B5C"/>
+                </a:solidFill>
+                <a:latin typeface="Calibri"/>
+              </a:defRPr>
+            </a:pPr>
+            <a:r>
+              <a:t>PRE-02 — Prediksi Probabilitas Keterlambatan Proyek Multi Sumber Daya Terbatas</a:t>
+            </a:r>
+          </a:p>
+        </p:txBody>
+      </p:sp>
+      <p:sp>
+        <p:nvSpPr>
+          <p:cNvPr id="6" name="TextBox 5"/>
+          <p:cNvSpPr txBox="1"/>
+          <p:nvPr/>
+        </p:nvSpPr>
+        <p:spPr>
+          <a:xfrm>
+            <a:off x="10972800" y="6492240"/>
+            <a:ext cx="457200" cy="274320"/>
+          </a:xfrm>
+          <a:prstGeom prst="rect">
+            <a:avLst/>
+          </a:prstGeom>
+          <a:noFill/>
+        </p:spPr>
+        <p:txBody>
+          <a:bodyPr wrap="square" lIns="0" tIns="0" rIns="0" bIns="0">
+            <a:spAutoFit/>
+          </a:bodyPr>
+          <a:lstStyle/>
+          <a:p>
+            <a:pPr>
+              <a:defRPr sz="900">
+                <a:solidFill>
+                  <a:srgbClr val="5B6B5C"/>
+                </a:solidFill>
+                <a:latin typeface="Calibri"/>
+              </a:defRPr>
+            </a:pPr>
+            <a:r>
+              <a:t>8</a:t>
+            </a:r>
+          </a:p>
+        </p:txBody>
+      </p:sp>
+      <p:graphicFrame>
+        <p:nvGraphicFramePr>
+          <p:cNvPr id="7" name="Table 6"/>
+          <p:cNvGraphicFramePr>
+            <a:graphicFrameLocks noGrp="1"/>
+          </p:cNvGraphicFramePr>
+          <p:nvPr/>
+        </p:nvGraphicFramePr>
+        <p:xfrm>
+          <a:off x="731520" y="1783080"/>
+          <a:ext cx="10698480" cy="3922776"/>
+        </p:xfrm>
+        <a:graphic>
+          <a:graphicData uri="http://schemas.openxmlformats.org/drawingml/2006/table">
+            <a:tbl>
+              <a:tblPr firstRow="1" bandRow="1">
+                <a:tableStyleId>{5C22544A-7EE6-4342-B048-85BDC9FD1C3A}</a:tableStyleId>
+              </a:tblPr>
+              <a:tblGrid>
+                <a:gridCol w="3383280"/>
+                <a:gridCol w="1280160"/>
+                <a:gridCol w="1188720"/>
+                <a:gridCol w="1280160"/>
+                <a:gridCol w="1188720"/>
+                <a:gridCol w="1097280"/>
+                <a:gridCol w="1280160"/>
+              </a:tblGrid>
+              <a:tr h="301752">
+                <a:tc>
+                  <a:txBody>
+                    <a:bodyPr/>
+                    <a:lstStyle/>
+                    <a:p>
+                      <a:pPr algn="ctr">
+                        <a:defRPr sz="1050" b="1">
+                          <a:solidFill>
+                            <a:srgbClr val="FFFFFF"/>
+                          </a:solidFill>
+                          <a:latin typeface="Calibri"/>
+                        </a:defRPr>
+                      </a:pPr>
+                      <a:r>
+                        <a:t>Model</a:t>
+                      </a:r>
+                    </a:p>
+                  </a:txBody>
+                  <a:tcPr marT="27432" marB="27432">
+                    <a:solidFill>
+                      <a:srgbClr val="1E4220"/>
+                    </a:solidFill>
+                  </a:tcPr>
+                </a:tc>
+                <a:tc>
+                  <a:txBody>
+                    <a:bodyPr/>
+                    <a:lstStyle/>
+                    <a:p>
+                      <a:pPr algn="ctr">
+                        <a:defRPr sz="1050" b="1">
+                          <a:solidFill>
+                            <a:srgbClr val="FFFFFF"/>
+                          </a:solidFill>
+                          <a:latin typeface="Calibri"/>
+                        </a:defRPr>
+                      </a:pPr>
+                      <a:r>
+                        <a:t>Kalibrasi</a:t>
+                      </a:r>
+                    </a:p>
+                  </a:txBody>
+                  <a:tcPr marT="27432" marB="27432">
+                    <a:solidFill>
+                      <a:srgbClr val="1E4220"/>
+                    </a:solidFill>
+                  </a:tcPr>
+                </a:tc>
+                <a:tc>
+                  <a:txBody>
+                    <a:bodyPr/>
+                    <a:lstStyle/>
+                    <a:p>
+                      <a:pPr algn="ctr">
+                        <a:defRPr sz="1050" b="1">
+                          <a:solidFill>
+                            <a:srgbClr val="FFFFFF"/>
+                          </a:solidFill>
+                          <a:latin typeface="Calibri"/>
+                        </a:defRPr>
+                      </a:pPr>
+                      <a:r>
+                        <a:t>ROC-AUC</a:t>
+                      </a:r>
+                    </a:p>
+                  </a:txBody>
+                  <a:tcPr marT="27432" marB="27432">
+                    <a:solidFill>
+                      <a:srgbClr val="1E4220"/>
+                    </a:solidFill>
+                  </a:tcPr>
+                </a:tc>
+                <a:tc>
+                  <a:txBody>
+                    <a:bodyPr/>
+                    <a:lstStyle/>
+                    <a:p>
+                      <a:pPr algn="ctr">
+                        <a:defRPr sz="1050" b="1">
+                          <a:solidFill>
+                            <a:srgbClr val="FFFFFF"/>
+                          </a:solidFill>
+                          <a:latin typeface="Calibri"/>
+                        </a:defRPr>
+                      </a:pPr>
+                      <a:r>
+                        <a:t>Brier Score</a:t>
+                      </a:r>
+                    </a:p>
+                  </a:txBody>
+                  <a:tcPr marT="27432" marB="27432">
+                    <a:solidFill>
+                      <a:srgbClr val="1E4220"/>
+                    </a:solidFill>
+                  </a:tcPr>
+                </a:tc>
+                <a:tc>
+                  <a:txBody>
+                    <a:bodyPr/>
+                    <a:lstStyle/>
+                    <a:p>
+                      <a:pPr algn="ctr">
+                        <a:defRPr sz="1050" b="1">
+                          <a:solidFill>
+                            <a:srgbClr val="FFFFFF"/>
+                          </a:solidFill>
+                          <a:latin typeface="Calibri"/>
+                        </a:defRPr>
+                      </a:pPr>
+                      <a:r>
+                        <a:t>Log Loss</a:t>
+                      </a:r>
+                    </a:p>
+                  </a:txBody>
+                  <a:tcPr marT="27432" marB="27432">
+                    <a:solidFill>
+                      <a:srgbClr val="1E4220"/>
+                    </a:solidFill>
+                  </a:tcPr>
+                </a:tc>
+                <a:tc>
+                  <a:txBody>
+                    <a:bodyPr/>
+                    <a:lstStyle/>
+                    <a:p>
+                      <a:pPr algn="ctr">
+                        <a:defRPr sz="1050" b="1">
+                          <a:solidFill>
+                            <a:srgbClr val="FFFFFF"/>
+                          </a:solidFill>
+                          <a:latin typeface="Calibri"/>
+                        </a:defRPr>
+                      </a:pPr>
+                      <a:r>
+                        <a:t>ECE</a:t>
+                      </a:r>
+                    </a:p>
+                  </a:txBody>
+                  <a:tcPr marT="27432" marB="27432">
+                    <a:solidFill>
+                      <a:srgbClr val="1E4220"/>
+                    </a:solidFill>
+                  </a:tcPr>
+                </a:tc>
+                <a:tc>
+                  <a:txBody>
+                    <a:bodyPr/>
+                    <a:lstStyle/>
+                    <a:p>
+                      <a:pPr algn="ctr">
+                        <a:defRPr sz="1050" b="1">
+                          <a:solidFill>
+                            <a:srgbClr val="FFFFFF"/>
+                          </a:solidFill>
+                          <a:latin typeface="Calibri"/>
+                        </a:defRPr>
+                      </a:pPr>
+                      <a:r>
+                        <a:t>Akurasi</a:t>
+                      </a:r>
+                    </a:p>
+                  </a:txBody>
+                  <a:tcPr marT="27432" marB="27432">
+                    <a:solidFill>
+                      <a:srgbClr val="1E4220"/>
+                    </a:solidFill>
+                  </a:tcPr>
+                </a:tc>
+              </a:tr>
+              <a:tr h="301752">
+                <a:tc>
+                  <a:txBody>
+                    <a:bodyPr/>
+                    <a:lstStyle/>
+                    <a:p>
+                      <a:pPr algn="l">
+                        <a:defRPr sz="1050" b="0">
+                          <a:solidFill>
+                            <a:srgbClr val="233324"/>
+                          </a:solidFill>
+                          <a:latin typeface="Calibri"/>
+                        </a:defRPr>
+                      </a:pPr>
+                      <a:r>
+                        <a:t>Logistic Regression (Baseline)</a:t>
+                      </a:r>
+                    </a:p>
+                  </a:txBody>
+                  <a:tcPr marT="27432" marB="27432">
+                    <a:solidFill>
+                      <a:srgbClr val="F4F7F1"/>
+                    </a:solidFill>
+                  </a:tcPr>
+                </a:tc>
+                <a:tc>
+                  <a:txBody>
+                    <a:bodyPr/>
+                    <a:lstStyle/>
+                    <a:p>
+                      <a:pPr algn="ctr">
+                        <a:defRPr sz="1050" b="0">
+                          <a:solidFill>
+                            <a:srgbClr val="233324"/>
+                          </a:solidFill>
+                          <a:latin typeface="Calibri"/>
+                        </a:defRPr>
+                      </a:pPr>
+                      <a:r>
+                        <a:t>Raw</a:t>
+                      </a:r>
+                    </a:p>
+                  </a:txBody>
+                  <a:tcPr marT="27432" marB="27432">
+                    <a:solidFill>
+                      <a:srgbClr val="F4F7F1"/>
+                    </a:solidFill>
+                  </a:tcPr>
+                </a:tc>
+                <a:tc>
+                  <a:txBody>
+                    <a:bodyPr/>
+                    <a:lstStyle/>
+                    <a:p>
+                      <a:pPr algn="ctr">
+                        <a:defRPr sz="1050" b="0">
+                          <a:solidFill>
+                            <a:srgbClr val="233324"/>
+                          </a:solidFill>
+                          <a:latin typeface="Calibri"/>
+                        </a:defRPr>
+                      </a:pPr>
+                      <a:r>
+                        <a:t>1.000</a:t>
+                      </a:r>
+                    </a:p>
+                  </a:txBody>
+                  <a:tcPr marT="27432" marB="27432">
+                    <a:solidFill>
+                      <a:srgbClr val="F4F7F1"/>
+                    </a:solidFill>
+                  </a:tcPr>
+                </a:tc>
+                <a:tc>
+                  <a:txBody>
+                    <a:bodyPr/>
+                    <a:lstStyle/>
+                    <a:p>
+                      <a:pPr algn="ctr">
+                        <a:defRPr sz="1050" b="0">
+                          <a:solidFill>
+                            <a:srgbClr val="233324"/>
+                          </a:solidFill>
+                          <a:latin typeface="Calibri"/>
+                        </a:defRPr>
+                      </a:pPr>
+                      <a:r>
+                        <a:t>0.0273</a:t>
+                      </a:r>
+                    </a:p>
+                  </a:txBody>
+                  <a:tcPr marT="27432" marB="27432">
+                    <a:solidFill>
+                      <a:srgbClr val="F4F7F1"/>
+                    </a:solidFill>
+                  </a:tcPr>
+                </a:tc>
+                <a:tc>
+                  <a:txBody>
+                    <a:bodyPr/>
+                    <a:lstStyle/>
+                    <a:p>
+                      <a:pPr algn="ctr">
+                        <a:defRPr sz="1050" b="0">
+                          <a:solidFill>
+                            <a:srgbClr val="233324"/>
+                          </a:solidFill>
+                          <a:latin typeface="Calibri"/>
+                        </a:defRPr>
+                      </a:pPr>
+                      <a:r>
+                        <a:t>0.116</a:t>
+                      </a:r>
+                    </a:p>
+                  </a:txBody>
+                  <a:tcPr marT="27432" marB="27432">
+                    <a:solidFill>
+                      <a:srgbClr val="F4F7F1"/>
+                    </a:solidFill>
+                  </a:tcPr>
+                </a:tc>
+                <a:tc>
+                  <a:txBody>
+                    <a:bodyPr/>
+                    <a:lstStyle/>
+                    <a:p>
+                      <a:pPr algn="ctr">
+                        <a:defRPr sz="1050" b="0">
+                          <a:solidFill>
+                            <a:srgbClr val="233324"/>
+                          </a:solidFill>
+                          <a:latin typeface="Calibri"/>
+                        </a:defRPr>
+                      </a:pPr>
+                      <a:r>
+                        <a:t>0.057</a:t>
+                      </a:r>
+                    </a:p>
+                  </a:txBody>
+                  <a:tcPr marT="27432" marB="27432">
+                    <a:solidFill>
+                      <a:srgbClr val="F4F7F1"/>
+                    </a:solidFill>
+                  </a:tcPr>
+                </a:tc>
+                <a:tc>
+                  <a:txBody>
+                    <a:bodyPr/>
+                    <a:lstStyle/>
+                    <a:p>
+                      <a:pPr algn="ctr">
+                        <a:defRPr sz="1050" b="0">
+                          <a:solidFill>
+                            <a:srgbClr val="233324"/>
+                          </a:solidFill>
+                          <a:latin typeface="Calibri"/>
+                        </a:defRPr>
+                      </a:pPr>
+                      <a:r>
+                        <a:t>96.2%</a:t>
+                      </a:r>
+                    </a:p>
+                  </a:txBody>
+                  <a:tcPr marT="27432" marB="27432">
+                    <a:solidFill>
+                      <a:srgbClr val="F4F7F1"/>
+                    </a:solidFill>
+                  </a:tcPr>
+                </a:tc>
+              </a:tr>
+              <a:tr h="301752">
+                <a:tc>
+                  <a:txBody>
+                    <a:bodyPr/>
+                    <a:lstStyle/>
+                    <a:p>
+                      <a:pPr algn="l">
+                        <a:defRPr sz="1050" b="0">
+                          <a:solidFill>
+                            <a:srgbClr val="233324"/>
+                          </a:solidFill>
+                          <a:latin typeface="Calibri"/>
+                        </a:defRPr>
+                      </a:pPr>
+                      <a:r>
+                        <a:t>Logistic Regression (Baseline)</a:t>
+                      </a:r>
+                    </a:p>
+                  </a:txBody>
+                  <a:tcPr marT="27432" marB="27432">
+                    <a:solidFill>
+                      <a:srgbClr val="FFFFFF"/>
+                    </a:solidFill>
+                  </a:tcPr>
+                </a:tc>
+                <a:tc>
+                  <a:txBody>
+                    <a:bodyPr/>
+                    <a:lstStyle/>
+                    <a:p>
+                      <a:pPr algn="ctr">
+                        <a:defRPr sz="1050" b="0">
+                          <a:solidFill>
+                            <a:srgbClr val="233324"/>
+                          </a:solidFill>
+                          <a:latin typeface="Calibri"/>
+                        </a:defRPr>
+                      </a:pPr>
+                      <a:r>
+                        <a:t>Platt</a:t>
+                      </a:r>
+                    </a:p>
+                  </a:txBody>
+                  <a:tcPr marT="27432" marB="27432">
+                    <a:solidFill>
+                      <a:srgbClr val="FFFFFF"/>
+                    </a:solidFill>
+                  </a:tcPr>
+                </a:tc>
+                <a:tc>
+                  <a:txBody>
+                    <a:bodyPr/>
+                    <a:lstStyle/>
+                    <a:p>
+                      <a:pPr algn="ctr">
+                        <a:defRPr sz="1050" b="0">
+                          <a:solidFill>
+                            <a:srgbClr val="233324"/>
+                          </a:solidFill>
+                          <a:latin typeface="Calibri"/>
+                        </a:defRPr>
+                      </a:pPr>
+                      <a:r>
+                        <a:t>1.000</a:t>
+                      </a:r>
+                    </a:p>
+                  </a:txBody>
+                  <a:tcPr marT="27432" marB="27432">
+                    <a:solidFill>
+                      <a:srgbClr val="FFFFFF"/>
+                    </a:solidFill>
+                  </a:tcPr>
+                </a:tc>
+                <a:tc>
+                  <a:txBody>
+                    <a:bodyPr/>
+                    <a:lstStyle/>
+                    <a:p>
+                      <a:pPr algn="ctr">
+                        <a:defRPr sz="1050" b="0">
+                          <a:solidFill>
+                            <a:srgbClr val="233324"/>
+                          </a:solidFill>
+                          <a:latin typeface="Calibri"/>
+                        </a:defRPr>
+                      </a:pPr>
+                      <a:r>
+                        <a:t>0.0317</a:t>
+                      </a:r>
+                    </a:p>
+                  </a:txBody>
+                  <a:tcPr marT="27432" marB="27432">
+                    <a:solidFill>
+                      <a:srgbClr val="FFFFFF"/>
+                    </a:solidFill>
+                  </a:tcPr>
+                </a:tc>
+                <a:tc>
+                  <a:txBody>
+                    <a:bodyPr/>
+                    <a:lstStyle/>
+                    <a:p>
+                      <a:pPr algn="ctr">
+                        <a:defRPr sz="1050" b="0">
+                          <a:solidFill>
+                            <a:srgbClr val="233324"/>
+                          </a:solidFill>
+                          <a:latin typeface="Calibri"/>
+                        </a:defRPr>
+                      </a:pPr>
+                      <a:r>
+                        <a:t>0.143</a:t>
+                      </a:r>
+                    </a:p>
+                  </a:txBody>
+                  <a:tcPr marT="27432" marB="27432">
+                    <a:solidFill>
+                      <a:srgbClr val="FFFFFF"/>
+                    </a:solidFill>
+                  </a:tcPr>
+                </a:tc>
+                <a:tc>
+                  <a:txBody>
+                    <a:bodyPr/>
+                    <a:lstStyle/>
+                    <a:p>
+                      <a:pPr algn="ctr">
+                        <a:defRPr sz="1050" b="0">
+                          <a:solidFill>
+                            <a:srgbClr val="233324"/>
+                          </a:solidFill>
+                          <a:latin typeface="Calibri"/>
+                        </a:defRPr>
+                      </a:pPr>
+                      <a:r>
+                        <a:t>0.075</a:t>
+                      </a:r>
+                    </a:p>
+                  </a:txBody>
+                  <a:tcPr marT="27432" marB="27432">
+                    <a:solidFill>
+                      <a:srgbClr val="FFFFFF"/>
+                    </a:solidFill>
+                  </a:tcPr>
+                </a:tc>
+                <a:tc>
+                  <a:txBody>
+                    <a:bodyPr/>
+                    <a:lstStyle/>
+                    <a:p>
+                      <a:pPr algn="ctr">
+                        <a:defRPr sz="1050" b="0">
+                          <a:solidFill>
+                            <a:srgbClr val="233324"/>
+                          </a:solidFill>
+                          <a:latin typeface="Calibri"/>
+                        </a:defRPr>
+                      </a:pPr>
+                      <a:r>
+                        <a:t>96.2%</a:t>
+                      </a:r>
+                    </a:p>
+                  </a:txBody>
+                  <a:tcPr marT="27432" marB="27432">
+                    <a:solidFill>
+                      <a:srgbClr val="FFFFFF"/>
+                    </a:solidFill>
+                  </a:tcPr>
+                </a:tc>
+              </a:tr>
+              <a:tr h="301752">
+                <a:tc>
+                  <a:txBody>
+                    <a:bodyPr/>
+                    <a:lstStyle/>
+                    <a:p>
+                      <a:pPr algn="l">
+                        <a:defRPr sz="1050" b="0">
+                          <a:solidFill>
+                            <a:srgbClr val="233324"/>
+                          </a:solidFill>
+                          <a:latin typeface="Calibri"/>
+                        </a:defRPr>
+                      </a:pPr>
+                      <a:r>
+                        <a:t>Logistic Regression (Baseline)</a:t>
+                      </a:r>
+                    </a:p>
+                  </a:txBody>
+                  <a:tcPr marT="27432" marB="27432">
+                    <a:solidFill>
+                      <a:srgbClr val="F4F7F1"/>
+                    </a:solidFill>
+                  </a:tcPr>
+                </a:tc>
+                <a:tc>
+                  <a:txBody>
+                    <a:bodyPr/>
+                    <a:lstStyle/>
+                    <a:p>
+                      <a:pPr algn="ctr">
+                        <a:defRPr sz="1050" b="0">
+                          <a:solidFill>
+                            <a:srgbClr val="233324"/>
+                          </a:solidFill>
+                          <a:latin typeface="Calibri"/>
+                        </a:defRPr>
+                      </a:pPr>
+                      <a:r>
+                        <a:t>Isotonic</a:t>
+                      </a:r>
+                    </a:p>
+                  </a:txBody>
+                  <a:tcPr marT="27432" marB="27432">
+                    <a:solidFill>
+                      <a:srgbClr val="F4F7F1"/>
+                    </a:solidFill>
+                  </a:tcPr>
+                </a:tc>
+                <a:tc>
+                  <a:txBody>
+                    <a:bodyPr/>
+                    <a:lstStyle/>
+                    <a:p>
+                      <a:pPr algn="ctr">
+                        <a:defRPr sz="1050" b="0">
+                          <a:solidFill>
+                            <a:srgbClr val="233324"/>
+                          </a:solidFill>
+                          <a:latin typeface="Calibri"/>
+                        </a:defRPr>
+                      </a:pPr>
+                      <a:r>
+                        <a:t>0.966</a:t>
+                      </a:r>
+                    </a:p>
+                  </a:txBody>
+                  <a:tcPr marT="27432" marB="27432">
+                    <a:solidFill>
+                      <a:srgbClr val="F4F7F1"/>
+                    </a:solidFill>
+                  </a:tcPr>
+                </a:tc>
+                <a:tc>
+                  <a:txBody>
+                    <a:bodyPr/>
+                    <a:lstStyle/>
+                    <a:p>
+                      <a:pPr algn="ctr">
+                        <a:defRPr sz="1050" b="0">
+                          <a:solidFill>
+                            <a:srgbClr val="233324"/>
+                          </a:solidFill>
+                          <a:latin typeface="Calibri"/>
+                        </a:defRPr>
+                      </a:pPr>
+                      <a:r>
+                        <a:t>0.0724</a:t>
+                      </a:r>
+                    </a:p>
+                  </a:txBody>
+                  <a:tcPr marT="27432" marB="27432">
+                    <a:solidFill>
+                      <a:srgbClr val="F4F7F1"/>
+                    </a:solidFill>
+                  </a:tcPr>
+                </a:tc>
+                <a:tc>
+                  <a:txBody>
+                    <a:bodyPr/>
+                    <a:lstStyle/>
+                    <a:p>
+                      <a:pPr algn="ctr">
+                        <a:defRPr sz="1050" b="0">
+                          <a:solidFill>
+                            <a:srgbClr val="233324"/>
+                          </a:solidFill>
+                          <a:latin typeface="Calibri"/>
+                        </a:defRPr>
+                      </a:pPr>
+                      <a:r>
+                        <a:t>1.437</a:t>
+                      </a:r>
+                    </a:p>
+                  </a:txBody>
+                  <a:tcPr marT="27432" marB="27432">
+                    <a:solidFill>
+                      <a:srgbClr val="F4F7F1"/>
+                    </a:solidFill>
+                  </a:tcPr>
+                </a:tc>
+                <a:tc>
+                  <a:txBody>
+                    <a:bodyPr/>
+                    <a:lstStyle/>
+                    <a:p>
+                      <a:pPr algn="ctr">
+                        <a:defRPr sz="1050" b="0">
+                          <a:solidFill>
+                            <a:srgbClr val="233324"/>
+                          </a:solidFill>
+                          <a:latin typeface="Calibri"/>
+                        </a:defRPr>
+                      </a:pPr>
+                      <a:r>
+                        <a:t>0.075</a:t>
+                      </a:r>
+                    </a:p>
+                  </a:txBody>
+                  <a:tcPr marT="27432" marB="27432">
+                    <a:solidFill>
+                      <a:srgbClr val="F4F7F1"/>
+                    </a:solidFill>
+                  </a:tcPr>
+                </a:tc>
+                <a:tc>
+                  <a:txBody>
+                    <a:bodyPr/>
+                    <a:lstStyle/>
+                    <a:p>
+                      <a:pPr algn="ctr">
+                        <a:defRPr sz="1050" b="0">
+                          <a:solidFill>
+                            <a:srgbClr val="233324"/>
+                          </a:solidFill>
+                          <a:latin typeface="Calibri"/>
+                        </a:defRPr>
+                      </a:pPr>
+                      <a:r>
+                        <a:t>92.3%</a:t>
+                      </a:r>
+                    </a:p>
+                  </a:txBody>
+                  <a:tcPr marT="27432" marB="27432">
+                    <a:solidFill>
+                      <a:srgbClr val="F4F7F1"/>
+                    </a:solidFill>
+                  </a:tcPr>
+                </a:tc>
+              </a:tr>
+              <a:tr h="301752">
+                <a:tc>
+                  <a:txBody>
+                    <a:bodyPr/>
+                    <a:lstStyle/>
+                    <a:p>
+                      <a:pPr algn="l">
+                        <a:defRPr sz="1050" b="0">
+                          <a:solidFill>
+                            <a:srgbClr val="233324"/>
+                          </a:solidFill>
+                          <a:latin typeface="Calibri"/>
+                        </a:defRPr>
+                      </a:pPr>
+                      <a:r>
+                        <a:t>Random Forest</a:t>
+                      </a:r>
+                    </a:p>
+                  </a:txBody>
+                  <a:tcPr marT="27432" marB="27432">
+                    <a:solidFill>
+                      <a:srgbClr val="FFFFFF"/>
+                    </a:solidFill>
+                  </a:tcPr>
+                </a:tc>
+                <a:tc>
+                  <a:txBody>
+                    <a:bodyPr/>
+                    <a:lstStyle/>
+                    <a:p>
+                      <a:pPr algn="ctr">
+                        <a:defRPr sz="1050" b="0">
+                          <a:solidFill>
+                            <a:srgbClr val="233324"/>
+                          </a:solidFill>
+                          <a:latin typeface="Calibri"/>
+                        </a:defRPr>
+                      </a:pPr>
+                      <a:r>
+                        <a:t>Raw</a:t>
+                      </a:r>
+                    </a:p>
+                  </a:txBody>
+                  <a:tcPr marT="27432" marB="27432">
+                    <a:solidFill>
+                      <a:srgbClr val="FFFFFF"/>
+                    </a:solidFill>
+                  </a:tcPr>
+                </a:tc>
+                <a:tc>
+                  <a:txBody>
+                    <a:bodyPr/>
+                    <a:lstStyle/>
+                    <a:p>
+                      <a:pPr algn="ctr">
+                        <a:defRPr sz="1050" b="0">
+                          <a:solidFill>
+                            <a:srgbClr val="233324"/>
+                          </a:solidFill>
+                          <a:latin typeface="Calibri"/>
+                        </a:defRPr>
+                      </a:pPr>
+                      <a:r>
+                        <a:t>0.987</a:t>
+                      </a:r>
+                    </a:p>
+                  </a:txBody>
+                  <a:tcPr marT="27432" marB="27432">
+                    <a:solidFill>
+                      <a:srgbClr val="FFFFFF"/>
+                    </a:solidFill>
+                  </a:tcPr>
+                </a:tc>
+                <a:tc>
+                  <a:txBody>
+                    <a:bodyPr/>
+                    <a:lstStyle/>
+                    <a:p>
+                      <a:pPr algn="ctr">
+                        <a:defRPr sz="1050" b="0">
+                          <a:solidFill>
+                            <a:srgbClr val="233324"/>
+                          </a:solidFill>
+                          <a:latin typeface="Calibri"/>
+                        </a:defRPr>
+                      </a:pPr>
+                      <a:r>
+                        <a:t>0.0421</a:t>
+                      </a:r>
+                    </a:p>
+                  </a:txBody>
+                  <a:tcPr marT="27432" marB="27432">
+                    <a:solidFill>
+                      <a:srgbClr val="FFFFFF"/>
+                    </a:solidFill>
+                  </a:tcPr>
+                </a:tc>
+                <a:tc>
+                  <a:txBody>
+                    <a:bodyPr/>
+                    <a:lstStyle/>
+                    <a:p>
+                      <a:pPr algn="ctr">
+                        <a:defRPr sz="1050" b="0">
+                          <a:solidFill>
+                            <a:srgbClr val="233324"/>
+                          </a:solidFill>
+                          <a:latin typeface="Calibri"/>
+                        </a:defRPr>
+                      </a:pPr>
+                      <a:r>
+                        <a:t>0.145</a:t>
+                      </a:r>
+                    </a:p>
+                  </a:txBody>
+                  <a:tcPr marT="27432" marB="27432">
+                    <a:solidFill>
+                      <a:srgbClr val="FFFFFF"/>
+                    </a:solidFill>
+                  </a:tcPr>
+                </a:tc>
+                <a:tc>
+                  <a:txBody>
+                    <a:bodyPr/>
+                    <a:lstStyle/>
+                    <a:p>
+                      <a:pPr algn="ctr">
+                        <a:defRPr sz="1050" b="0">
+                          <a:solidFill>
+                            <a:srgbClr val="233324"/>
+                          </a:solidFill>
+                          <a:latin typeface="Calibri"/>
+                        </a:defRPr>
+                      </a:pPr>
+                      <a:r>
+                        <a:t>0.081</a:t>
+                      </a:r>
+                    </a:p>
+                  </a:txBody>
+                  <a:tcPr marT="27432" marB="27432">
+                    <a:solidFill>
+                      <a:srgbClr val="FFFFFF"/>
+                    </a:solidFill>
+                  </a:tcPr>
+                </a:tc>
+                <a:tc>
+                  <a:txBody>
+                    <a:bodyPr/>
+                    <a:lstStyle/>
+                    <a:p>
+                      <a:pPr algn="ctr">
+                        <a:defRPr sz="1050" b="0">
+                          <a:solidFill>
+                            <a:srgbClr val="233324"/>
+                          </a:solidFill>
+                          <a:latin typeface="Calibri"/>
+                        </a:defRPr>
+                      </a:pPr>
+                      <a:r>
+                        <a:t>92.3%</a:t>
+                      </a:r>
+                    </a:p>
+                  </a:txBody>
+                  <a:tcPr marT="27432" marB="27432">
+                    <a:solidFill>
+                      <a:srgbClr val="FFFFFF"/>
+                    </a:solidFill>
+                  </a:tcPr>
+                </a:tc>
+              </a:tr>
+              <a:tr h="301752">
+                <a:tc>
+                  <a:txBody>
+                    <a:bodyPr/>
+                    <a:lstStyle/>
+                    <a:p>
+                      <a:pPr algn="l">
+                        <a:defRPr sz="1050" b="0">
+                          <a:solidFill>
+                            <a:srgbClr val="233324"/>
+                          </a:solidFill>
+                          <a:latin typeface="Calibri"/>
+                        </a:defRPr>
+                      </a:pPr>
+                      <a:r>
+                        <a:t>Random Forest</a:t>
+                      </a:r>
+                    </a:p>
+                  </a:txBody>
+                  <a:tcPr marT="27432" marB="27432">
+                    <a:solidFill>
+                      <a:srgbClr val="F4F7F1"/>
+                    </a:solidFill>
+                  </a:tcPr>
+                </a:tc>
+                <a:tc>
+                  <a:txBody>
+                    <a:bodyPr/>
+                    <a:lstStyle/>
+                    <a:p>
+                      <a:pPr algn="ctr">
+                        <a:defRPr sz="1050" b="0">
+                          <a:solidFill>
+                            <a:srgbClr val="233324"/>
+                          </a:solidFill>
+                          <a:latin typeface="Calibri"/>
+                        </a:defRPr>
+                      </a:pPr>
+                      <a:r>
+                        <a:t>Platt</a:t>
+                      </a:r>
+                    </a:p>
+                  </a:txBody>
+                  <a:tcPr marT="27432" marB="27432">
+                    <a:solidFill>
+                      <a:srgbClr val="F4F7F1"/>
+                    </a:solidFill>
+                  </a:tcPr>
+                </a:tc>
+                <a:tc>
+                  <a:txBody>
+                    <a:bodyPr/>
+                    <a:lstStyle/>
+                    <a:p>
+                      <a:pPr algn="ctr">
+                        <a:defRPr sz="1050" b="0">
+                          <a:solidFill>
+                            <a:srgbClr val="233324"/>
+                          </a:solidFill>
+                          <a:latin typeface="Calibri"/>
+                        </a:defRPr>
+                      </a:pPr>
+                      <a:r>
+                        <a:t>1.000</a:t>
+                      </a:r>
+                    </a:p>
+                  </a:txBody>
+                  <a:tcPr marT="27432" marB="27432">
+                    <a:solidFill>
+                      <a:srgbClr val="F4F7F1"/>
+                    </a:solidFill>
+                  </a:tcPr>
+                </a:tc>
+                <a:tc>
+                  <a:txBody>
+                    <a:bodyPr/>
+                    <a:lstStyle/>
+                    <a:p>
+                      <a:pPr algn="ctr">
+                        <a:defRPr sz="1050" b="0">
+                          <a:solidFill>
+                            <a:srgbClr val="233324"/>
+                          </a:solidFill>
+                          <a:latin typeface="Calibri"/>
+                        </a:defRPr>
+                      </a:pPr>
+                      <a:r>
+                        <a:t>0.0696</a:t>
+                      </a:r>
+                    </a:p>
+                  </a:txBody>
+                  <a:tcPr marT="27432" marB="27432">
+                    <a:solidFill>
+                      <a:srgbClr val="F4F7F1"/>
+                    </a:solidFill>
+                  </a:tcPr>
+                </a:tc>
+                <a:tc>
+                  <a:txBody>
+                    <a:bodyPr/>
+                    <a:lstStyle/>
+                    <a:p>
+                      <a:pPr algn="ctr">
+                        <a:defRPr sz="1050" b="0">
+                          <a:solidFill>
+                            <a:srgbClr val="233324"/>
+                          </a:solidFill>
+                          <a:latin typeface="Calibri"/>
+                        </a:defRPr>
+                      </a:pPr>
+                      <a:r>
+                        <a:t>0.242</a:t>
+                      </a:r>
+                    </a:p>
+                  </a:txBody>
+                  <a:tcPr marT="27432" marB="27432">
+                    <a:solidFill>
+                      <a:srgbClr val="F4F7F1"/>
+                    </a:solidFill>
+                  </a:tcPr>
+                </a:tc>
+                <a:tc>
+                  <a:txBody>
+                    <a:bodyPr/>
+                    <a:lstStyle/>
+                    <a:p>
+                      <a:pPr algn="ctr">
+                        <a:defRPr sz="1050" b="0">
+                          <a:solidFill>
+                            <a:srgbClr val="233324"/>
+                          </a:solidFill>
+                          <a:latin typeface="Calibri"/>
+                        </a:defRPr>
+                      </a:pPr>
+                      <a:r>
+                        <a:t>0.122</a:t>
+                      </a:r>
+                    </a:p>
+                  </a:txBody>
+                  <a:tcPr marT="27432" marB="27432">
+                    <a:solidFill>
+                      <a:srgbClr val="F4F7F1"/>
+                    </a:solidFill>
+                  </a:tcPr>
+                </a:tc>
+                <a:tc>
+                  <a:txBody>
+                    <a:bodyPr/>
+                    <a:lstStyle/>
+                    <a:p>
+                      <a:pPr algn="ctr">
+                        <a:defRPr sz="1050" b="0">
+                          <a:solidFill>
+                            <a:srgbClr val="233324"/>
+                          </a:solidFill>
+                          <a:latin typeface="Calibri"/>
+                        </a:defRPr>
+                      </a:pPr>
+                      <a:r>
+                        <a:t>96.2%</a:t>
+                      </a:r>
+                    </a:p>
+                  </a:txBody>
+                  <a:tcPr marT="27432" marB="27432">
+                    <a:solidFill>
+                      <a:srgbClr val="F4F7F1"/>
+                    </a:solidFill>
+                  </a:tcPr>
+                </a:tc>
+              </a:tr>
+              <a:tr h="301752">
+                <a:tc>
+                  <a:txBody>
+                    <a:bodyPr/>
+                    <a:lstStyle/>
+                    <a:p>
+                      <a:pPr algn="l">
+                        <a:defRPr sz="1050" b="0">
+                          <a:solidFill>
+                            <a:srgbClr val="233324"/>
+                          </a:solidFill>
+                          <a:latin typeface="Calibri"/>
+                        </a:defRPr>
+                      </a:pPr>
+                      <a:r>
+                        <a:t>Random Forest</a:t>
+                      </a:r>
+                    </a:p>
+                  </a:txBody>
+                  <a:tcPr marT="27432" marB="27432">
+                    <a:solidFill>
+                      <a:srgbClr val="FFFFFF"/>
+                    </a:solidFill>
+                  </a:tcPr>
+                </a:tc>
+                <a:tc>
+                  <a:txBody>
+                    <a:bodyPr/>
+                    <a:lstStyle/>
+                    <a:p>
+                      <a:pPr algn="ctr">
+                        <a:defRPr sz="1050" b="0">
+                          <a:solidFill>
+                            <a:srgbClr val="233324"/>
+                          </a:solidFill>
+                          <a:latin typeface="Calibri"/>
+                        </a:defRPr>
+                      </a:pPr>
+                      <a:r>
+                        <a:t>Isotonic</a:t>
+                      </a:r>
+                    </a:p>
+                  </a:txBody>
+                  <a:tcPr marT="27432" marB="27432">
+                    <a:solidFill>
+                      <a:srgbClr val="FFFFFF"/>
+                    </a:solidFill>
+                  </a:tcPr>
+                </a:tc>
+                <a:tc>
+                  <a:txBody>
+                    <a:bodyPr/>
+                    <a:lstStyle/>
+                    <a:p>
+                      <a:pPr algn="ctr">
+                        <a:defRPr sz="1050" b="0">
+                          <a:solidFill>
+                            <a:srgbClr val="233324"/>
+                          </a:solidFill>
+                          <a:latin typeface="Calibri"/>
+                        </a:defRPr>
+                      </a:pPr>
+                      <a:r>
+                        <a:t>0.916</a:t>
+                      </a:r>
+                    </a:p>
+                  </a:txBody>
+                  <a:tcPr marT="27432" marB="27432">
+                    <a:solidFill>
+                      <a:srgbClr val="FFFFFF"/>
+                    </a:solidFill>
+                  </a:tcPr>
+                </a:tc>
+                <a:tc>
+                  <a:txBody>
+                    <a:bodyPr/>
+                    <a:lstStyle/>
+                    <a:p>
+                      <a:pPr algn="ctr">
+                        <a:defRPr sz="1050" b="0">
+                          <a:solidFill>
+                            <a:srgbClr val="233324"/>
+                          </a:solidFill>
+                          <a:latin typeface="Calibri"/>
+                        </a:defRPr>
+                      </a:pPr>
+                      <a:r>
+                        <a:t>0.0801</a:t>
+                      </a:r>
+                    </a:p>
+                  </a:txBody>
+                  <a:tcPr marT="27432" marB="27432">
+                    <a:solidFill>
+                      <a:srgbClr val="FFFFFF"/>
+                    </a:solidFill>
+                  </a:tcPr>
+                </a:tc>
+                <a:tc>
+                  <a:txBody>
+                    <a:bodyPr/>
+                    <a:lstStyle/>
+                    <a:p>
+                      <a:pPr algn="ctr">
+                        <a:defRPr sz="1050" b="0">
+                          <a:solidFill>
+                            <a:srgbClr val="233324"/>
+                          </a:solidFill>
+                          <a:latin typeface="Calibri"/>
+                        </a:defRPr>
+                      </a:pPr>
+                      <a:r>
+                        <a:t>2.670</a:t>
+                      </a:r>
+                    </a:p>
+                  </a:txBody>
+                  <a:tcPr marT="27432" marB="27432">
+                    <a:solidFill>
+                      <a:srgbClr val="FFFFFF"/>
+                    </a:solidFill>
+                  </a:tcPr>
+                </a:tc>
+                <a:tc>
+                  <a:txBody>
+                    <a:bodyPr/>
+                    <a:lstStyle/>
+                    <a:p>
+                      <a:pPr algn="ctr">
+                        <a:defRPr sz="1050" b="0">
+                          <a:solidFill>
+                            <a:srgbClr val="233324"/>
+                          </a:solidFill>
+                          <a:latin typeface="Calibri"/>
+                        </a:defRPr>
+                      </a:pPr>
+                      <a:r>
+                        <a:t>0.088</a:t>
+                      </a:r>
+                    </a:p>
+                  </a:txBody>
+                  <a:tcPr marT="27432" marB="27432">
+                    <a:solidFill>
+                      <a:srgbClr val="FFFFFF"/>
+                    </a:solidFill>
+                  </a:tcPr>
+                </a:tc>
+                <a:tc>
+                  <a:txBody>
+                    <a:bodyPr/>
+                    <a:lstStyle/>
+                    <a:p>
+                      <a:pPr algn="ctr">
+                        <a:defRPr sz="1050" b="0">
+                          <a:solidFill>
+                            <a:srgbClr val="233324"/>
+                          </a:solidFill>
+                          <a:latin typeface="Calibri"/>
+                        </a:defRPr>
+                      </a:pPr>
+                      <a:r>
+                        <a:t>92.3%</a:t>
+                      </a:r>
+                    </a:p>
+                  </a:txBody>
+                  <a:tcPr marT="27432" marB="27432">
+                    <a:solidFill>
+                      <a:srgbClr val="FFFFFF"/>
+                    </a:solidFill>
+                  </a:tcPr>
+                </a:tc>
+              </a:tr>
+              <a:tr h="301752">
+                <a:tc>
+                  <a:txBody>
+                    <a:bodyPr/>
+                    <a:lstStyle/>
+                    <a:p>
+                      <a:pPr algn="l">
+                        <a:defRPr sz="1050" b="0">
+                          <a:solidFill>
+                            <a:srgbClr val="233324"/>
+                          </a:solidFill>
+                          <a:latin typeface="Calibri"/>
+                        </a:defRPr>
+                      </a:pPr>
+                      <a:r>
+                        <a:t>Gradient Boosting</a:t>
+                      </a:r>
+                    </a:p>
+                  </a:txBody>
+                  <a:tcPr marT="27432" marB="27432">
+                    <a:solidFill>
+                      <a:srgbClr val="F4F7F1"/>
+                    </a:solidFill>
+                  </a:tcPr>
+                </a:tc>
+                <a:tc>
+                  <a:txBody>
+                    <a:bodyPr/>
+                    <a:lstStyle/>
+                    <a:p>
+                      <a:pPr algn="ctr">
+                        <a:defRPr sz="1050" b="0">
+                          <a:solidFill>
+                            <a:srgbClr val="233324"/>
+                          </a:solidFill>
+                          <a:latin typeface="Calibri"/>
+                        </a:defRPr>
+                      </a:pPr>
+                      <a:r>
+                        <a:t>Raw</a:t>
+                      </a:r>
+                    </a:p>
+                  </a:txBody>
+                  <a:tcPr marT="27432" marB="27432">
+                    <a:solidFill>
+                      <a:srgbClr val="F4F7F1"/>
+                    </a:solidFill>
+                  </a:tcPr>
+                </a:tc>
+                <a:tc>
+                  <a:txBody>
+                    <a:bodyPr/>
+                    <a:lstStyle/>
+                    <a:p>
+                      <a:pPr algn="ctr">
+                        <a:defRPr sz="1050" b="0">
+                          <a:solidFill>
+                            <a:srgbClr val="233324"/>
+                          </a:solidFill>
+                          <a:latin typeface="Calibri"/>
+                        </a:defRPr>
+                      </a:pPr>
+                      <a:r>
+                        <a:t>0.903</a:t>
+                      </a:r>
+                    </a:p>
+                  </a:txBody>
+                  <a:tcPr marT="27432" marB="27432">
+                    <a:solidFill>
+                      <a:srgbClr val="F4F7F1"/>
+                    </a:solidFill>
+                  </a:tcPr>
+                </a:tc>
+                <a:tc>
+                  <a:txBody>
+                    <a:bodyPr/>
+                    <a:lstStyle/>
+                    <a:p>
+                      <a:pPr algn="ctr">
+                        <a:defRPr sz="1050" b="0">
+                          <a:solidFill>
+                            <a:srgbClr val="233324"/>
+                          </a:solidFill>
+                          <a:latin typeface="Calibri"/>
+                        </a:defRPr>
+                      </a:pPr>
+                      <a:r>
+                        <a:t>0.0973</a:t>
+                      </a:r>
+                    </a:p>
+                  </a:txBody>
+                  <a:tcPr marT="27432" marB="27432">
+                    <a:solidFill>
+                      <a:srgbClr val="F4F7F1"/>
+                    </a:solidFill>
+                  </a:tcPr>
+                </a:tc>
+                <a:tc>
+                  <a:txBody>
+                    <a:bodyPr/>
+                    <a:lstStyle/>
+                    <a:p>
+                      <a:pPr algn="ctr">
+                        <a:defRPr sz="1050" b="0">
+                          <a:solidFill>
+                            <a:srgbClr val="233324"/>
+                          </a:solidFill>
+                          <a:latin typeface="Calibri"/>
+                        </a:defRPr>
+                      </a:pPr>
+                      <a:r>
+                        <a:t>0.489</a:t>
+                      </a:r>
+                    </a:p>
+                  </a:txBody>
+                  <a:tcPr marT="27432" marB="27432">
+                    <a:solidFill>
+                      <a:srgbClr val="F4F7F1"/>
+                    </a:solidFill>
+                  </a:tcPr>
+                </a:tc>
+                <a:tc>
+                  <a:txBody>
+                    <a:bodyPr/>
+                    <a:lstStyle/>
+                    <a:p>
+                      <a:pPr algn="ctr">
+                        <a:defRPr sz="1050" b="0">
+                          <a:solidFill>
+                            <a:srgbClr val="233324"/>
+                          </a:solidFill>
+                          <a:latin typeface="Calibri"/>
+                        </a:defRPr>
+                      </a:pPr>
+                      <a:r>
+                        <a:t>0.101</a:t>
+                      </a:r>
+                    </a:p>
+                  </a:txBody>
+                  <a:tcPr marT="27432" marB="27432">
+                    <a:solidFill>
+                      <a:srgbClr val="F4F7F1"/>
+                    </a:solidFill>
+                  </a:tcPr>
+                </a:tc>
+                <a:tc>
+                  <a:txBody>
+                    <a:bodyPr/>
+                    <a:lstStyle/>
+                    <a:p>
+                      <a:pPr algn="ctr">
+                        <a:defRPr sz="1050" b="0">
+                          <a:solidFill>
+                            <a:srgbClr val="233324"/>
+                          </a:solidFill>
+                          <a:latin typeface="Calibri"/>
+                        </a:defRPr>
+                      </a:pPr>
+                      <a:r>
+                        <a:t>88.5%</a:t>
+                      </a:r>
+                    </a:p>
+                  </a:txBody>
+                  <a:tcPr marT="27432" marB="27432">
+                    <a:solidFill>
+                      <a:srgbClr val="F4F7F1"/>
+                    </a:solidFill>
+                  </a:tcPr>
+                </a:tc>
+              </a:tr>
+              <a:tr h="301752">
+                <a:tc>
+                  <a:txBody>
+                    <a:bodyPr/>
+                    <a:lstStyle/>
+                    <a:p>
+                      <a:pPr algn="l">
+                        <a:defRPr sz="1050" b="0">
+                          <a:solidFill>
+                            <a:srgbClr val="233324"/>
+                          </a:solidFill>
+                          <a:latin typeface="Calibri"/>
+                        </a:defRPr>
+                      </a:pPr>
+                      <a:r>
+                        <a:t>Gradient Boosting</a:t>
+                      </a:r>
+                    </a:p>
+                  </a:txBody>
+                  <a:tcPr marT="27432" marB="27432">
+                    <a:solidFill>
+                      <a:srgbClr val="FFFFFF"/>
+                    </a:solidFill>
+                  </a:tcPr>
+                </a:tc>
+                <a:tc>
+                  <a:txBody>
+                    <a:bodyPr/>
+                    <a:lstStyle/>
+                    <a:p>
+                      <a:pPr algn="ctr">
+                        <a:defRPr sz="1050" b="0">
+                          <a:solidFill>
+                            <a:srgbClr val="233324"/>
+                          </a:solidFill>
+                          <a:latin typeface="Calibri"/>
+                        </a:defRPr>
+                      </a:pPr>
+                      <a:r>
+                        <a:t>Platt</a:t>
+                      </a:r>
+                    </a:p>
+                  </a:txBody>
+                  <a:tcPr marT="27432" marB="27432">
+                    <a:solidFill>
+                      <a:srgbClr val="FFFFFF"/>
+                    </a:solidFill>
+                  </a:tcPr>
+                </a:tc>
+                <a:tc>
+                  <a:txBody>
+                    <a:bodyPr/>
+                    <a:lstStyle/>
+                    <a:p>
+                      <a:pPr algn="ctr">
+                        <a:defRPr sz="1050" b="0">
+                          <a:solidFill>
+                            <a:srgbClr val="233324"/>
+                          </a:solidFill>
+                          <a:latin typeface="Calibri"/>
+                        </a:defRPr>
+                      </a:pPr>
+                      <a:r>
+                        <a:t>0.866</a:t>
+                      </a:r>
+                    </a:p>
+                  </a:txBody>
+                  <a:tcPr marT="27432" marB="27432">
+                    <a:solidFill>
+                      <a:srgbClr val="FFFFFF"/>
+                    </a:solidFill>
+                  </a:tcPr>
+                </a:tc>
+                <a:tc>
+                  <a:txBody>
+                    <a:bodyPr/>
+                    <a:lstStyle/>
+                    <a:p>
+                      <a:pPr algn="ctr">
+                        <a:defRPr sz="1050" b="0">
+                          <a:solidFill>
+                            <a:srgbClr val="233324"/>
+                          </a:solidFill>
+                          <a:latin typeface="Calibri"/>
+                        </a:defRPr>
+                      </a:pPr>
+                      <a:r>
+                        <a:t>0.0936</a:t>
+                      </a:r>
+                    </a:p>
+                  </a:txBody>
+                  <a:tcPr marT="27432" marB="27432">
+                    <a:solidFill>
+                      <a:srgbClr val="FFFFFF"/>
+                    </a:solidFill>
+                  </a:tcPr>
+                </a:tc>
+                <a:tc>
+                  <a:txBody>
+                    <a:bodyPr/>
+                    <a:lstStyle/>
+                    <a:p>
+                      <a:pPr algn="ctr">
+                        <a:defRPr sz="1050" b="0">
+                          <a:solidFill>
+                            <a:srgbClr val="233324"/>
+                          </a:solidFill>
+                          <a:latin typeface="Calibri"/>
+                        </a:defRPr>
+                      </a:pPr>
+                      <a:r>
+                        <a:t>0.349</a:t>
+                      </a:r>
+                    </a:p>
+                  </a:txBody>
+                  <a:tcPr marT="27432" marB="27432">
+                    <a:solidFill>
+                      <a:srgbClr val="FFFFFF"/>
+                    </a:solidFill>
+                  </a:tcPr>
+                </a:tc>
+                <a:tc>
+                  <a:txBody>
+                    <a:bodyPr/>
+                    <a:lstStyle/>
+                    <a:p>
+                      <a:pPr algn="ctr">
+                        <a:defRPr sz="1050" b="0">
+                          <a:solidFill>
+                            <a:srgbClr val="233324"/>
+                          </a:solidFill>
+                          <a:latin typeface="Calibri"/>
+                        </a:defRPr>
+                      </a:pPr>
+                      <a:r>
+                        <a:t>0.071</a:t>
+                      </a:r>
+                    </a:p>
+                  </a:txBody>
+                  <a:tcPr marT="27432" marB="27432">
+                    <a:solidFill>
+                      <a:srgbClr val="FFFFFF"/>
+                    </a:solidFill>
+                  </a:tcPr>
+                </a:tc>
+                <a:tc>
+                  <a:txBody>
+                    <a:bodyPr/>
+                    <a:lstStyle/>
+                    <a:p>
+                      <a:pPr algn="ctr">
+                        <a:defRPr sz="1050" b="0">
+                          <a:solidFill>
+                            <a:srgbClr val="233324"/>
+                          </a:solidFill>
+                          <a:latin typeface="Calibri"/>
+                        </a:defRPr>
+                      </a:pPr>
+                      <a:r>
+                        <a:t>88.5%</a:t>
+                      </a:r>
+                    </a:p>
+                  </a:txBody>
+                  <a:tcPr marT="27432" marB="27432">
+                    <a:solidFill>
+                      <a:srgbClr val="FFFFFF"/>
+                    </a:solidFill>
+                  </a:tcPr>
+                </a:tc>
+              </a:tr>
+              <a:tr h="301752">
+                <a:tc>
+                  <a:txBody>
+                    <a:bodyPr/>
+                    <a:lstStyle/>
+                    <a:p>
+                      <a:pPr algn="l">
+                        <a:defRPr sz="1050" b="0">
+                          <a:solidFill>
+                            <a:srgbClr val="233324"/>
+                          </a:solidFill>
+                          <a:latin typeface="Calibri"/>
+                        </a:defRPr>
+                      </a:pPr>
+                      <a:r>
+                        <a:t>Gradient Boosting</a:t>
+                      </a:r>
+                    </a:p>
+                  </a:txBody>
+                  <a:tcPr marT="27432" marB="27432">
+                    <a:solidFill>
+                      <a:srgbClr val="F4F7F1"/>
+                    </a:solidFill>
+                  </a:tcPr>
+                </a:tc>
+                <a:tc>
+                  <a:txBody>
+                    <a:bodyPr/>
+                    <a:lstStyle/>
+                    <a:p>
+                      <a:pPr algn="ctr">
+                        <a:defRPr sz="1050" b="0">
+                          <a:solidFill>
+                            <a:srgbClr val="233324"/>
+                          </a:solidFill>
+                          <a:latin typeface="Calibri"/>
+                        </a:defRPr>
+                      </a:pPr>
+                      <a:r>
+                        <a:t>Isotonic</a:t>
+                      </a:r>
+                    </a:p>
+                  </a:txBody>
+                  <a:tcPr marT="27432" marB="27432">
+                    <a:solidFill>
+                      <a:srgbClr val="F4F7F1"/>
+                    </a:solidFill>
+                  </a:tcPr>
+                </a:tc>
+                <a:tc>
+                  <a:txBody>
+                    <a:bodyPr/>
+                    <a:lstStyle/>
+                    <a:p>
+                      <a:pPr algn="ctr">
+                        <a:defRPr sz="1050" b="0">
+                          <a:solidFill>
+                            <a:srgbClr val="233324"/>
+                          </a:solidFill>
+                          <a:latin typeface="Calibri"/>
+                        </a:defRPr>
+                      </a:pPr>
+                      <a:r>
+                        <a:t>0.878</a:t>
+                      </a:r>
+                    </a:p>
+                  </a:txBody>
+                  <a:tcPr marT="27432" marB="27432">
+                    <a:solidFill>
+                      <a:srgbClr val="F4F7F1"/>
+                    </a:solidFill>
+                  </a:tcPr>
+                </a:tc>
+                <a:tc>
+                  <a:txBody>
+                    <a:bodyPr/>
+                    <a:lstStyle/>
+                    <a:p>
+                      <a:pPr algn="ctr">
+                        <a:defRPr sz="1050" b="0">
+                          <a:solidFill>
+                            <a:srgbClr val="233324"/>
+                          </a:solidFill>
+                          <a:latin typeface="Calibri"/>
+                        </a:defRPr>
+                      </a:pPr>
+                      <a:r>
+                        <a:t>0.1007</a:t>
+                      </a:r>
+                    </a:p>
+                  </a:txBody>
+                  <a:tcPr marT="27432" marB="27432">
+                    <a:solidFill>
+                      <a:srgbClr val="F4F7F1"/>
+                    </a:solidFill>
+                  </a:tcPr>
+                </a:tc>
+                <a:tc>
+                  <a:txBody>
+                    <a:bodyPr/>
+                    <a:lstStyle/>
+                    <a:p>
+                      <a:pPr algn="ctr">
+                        <a:defRPr sz="1050" b="0">
+                          <a:solidFill>
+                            <a:srgbClr val="233324"/>
+                          </a:solidFill>
+                          <a:latin typeface="Calibri"/>
+                        </a:defRPr>
+                      </a:pPr>
+                      <a:r>
+                        <a:t>2.751</a:t>
+                      </a:r>
+                    </a:p>
+                  </a:txBody>
+                  <a:tcPr marT="27432" marB="27432">
+                    <a:solidFill>
+                      <a:srgbClr val="F4F7F1"/>
+                    </a:solidFill>
+                  </a:tcPr>
+                </a:tc>
+                <a:tc>
+                  <a:txBody>
+                    <a:bodyPr/>
+                    <a:lstStyle/>
+                    <a:p>
+                      <a:pPr algn="ctr">
+                        <a:defRPr sz="1050" b="0">
+                          <a:solidFill>
+                            <a:srgbClr val="233324"/>
+                          </a:solidFill>
+                          <a:latin typeface="Calibri"/>
+                        </a:defRPr>
+                      </a:pPr>
+                      <a:r>
+                        <a:t>0.059</a:t>
+                      </a:r>
+                    </a:p>
+                  </a:txBody>
+                  <a:tcPr marT="27432" marB="27432">
+                    <a:solidFill>
+                      <a:srgbClr val="F4F7F1"/>
+                    </a:solidFill>
+                  </a:tcPr>
+                </a:tc>
+                <a:tc>
+                  <a:txBody>
+                    <a:bodyPr/>
+                    <a:lstStyle/>
+                    <a:p>
+                      <a:pPr algn="ctr">
+                        <a:defRPr sz="1050" b="0">
+                          <a:solidFill>
+                            <a:srgbClr val="233324"/>
+                          </a:solidFill>
+                          <a:latin typeface="Calibri"/>
+                        </a:defRPr>
+                      </a:pPr>
+                      <a:r>
+                        <a:t>88.5%</a:t>
+                      </a:r>
+                    </a:p>
+                  </a:txBody>
+                  <a:tcPr marT="27432" marB="27432">
+                    <a:solidFill>
+                      <a:srgbClr val="F4F7F1"/>
+                    </a:solidFill>
+                  </a:tcPr>
+                </a:tc>
+              </a:tr>
+              <a:tr h="301752">
+                <a:tc>
+                  <a:txBody>
+                    <a:bodyPr/>
+                    <a:lstStyle/>
+                    <a:p>
+                      <a:pPr algn="l">
+                        <a:defRPr sz="1050" b="1">
+                          <a:solidFill>
+                            <a:srgbClr val="233324"/>
+                          </a:solidFill>
+                          <a:latin typeface="Calibri"/>
+                        </a:defRPr>
+                      </a:pPr>
+                      <a:r>
+                        <a:t>MLP Neural Network</a:t>
+                      </a:r>
+                    </a:p>
+                  </a:txBody>
+                  <a:tcPr marT="27432" marB="27432">
+                    <a:solidFill>
+                      <a:srgbClr val="E4EFD8"/>
+                    </a:solidFill>
+                  </a:tcPr>
+                </a:tc>
+                <a:tc>
+                  <a:txBody>
+                    <a:bodyPr/>
+                    <a:lstStyle/>
+                    <a:p>
+                      <a:pPr algn="ctr">
+                        <a:defRPr sz="1050" b="1">
+                          <a:solidFill>
+                            <a:srgbClr val="233324"/>
+                          </a:solidFill>
+                          <a:latin typeface="Calibri"/>
+                        </a:defRPr>
+                      </a:pPr>
+                      <a:r>
+                        <a:t>Raw</a:t>
+                      </a:r>
+                    </a:p>
+                  </a:txBody>
+                  <a:tcPr marT="27432" marB="27432">
+                    <a:solidFill>
+                      <a:srgbClr val="E4EFD8"/>
+                    </a:solidFill>
+                  </a:tcPr>
+                </a:tc>
+                <a:tc>
+                  <a:txBody>
+                    <a:bodyPr/>
+                    <a:lstStyle/>
+                    <a:p>
+                      <a:pPr algn="ctr">
+                        <a:defRPr sz="1050" b="1">
+                          <a:solidFill>
+                            <a:srgbClr val="233324"/>
+                          </a:solidFill>
+                          <a:latin typeface="Calibri"/>
+                        </a:defRPr>
+                      </a:pPr>
+                      <a:r>
+                        <a:t>1.000</a:t>
+                      </a:r>
+                    </a:p>
+                  </a:txBody>
+                  <a:tcPr marT="27432" marB="27432">
+                    <a:solidFill>
+                      <a:srgbClr val="E4EFD8"/>
+                    </a:solidFill>
+                  </a:tcPr>
+                </a:tc>
+                <a:tc>
+                  <a:txBody>
+                    <a:bodyPr/>
+                    <a:lstStyle/>
+                    <a:p>
+                      <a:pPr algn="ctr">
+                        <a:defRPr sz="1050" b="1">
+                          <a:solidFill>
+                            <a:srgbClr val="233324"/>
+                          </a:solidFill>
+                          <a:latin typeface="Calibri"/>
+                        </a:defRPr>
+                      </a:pPr>
+                      <a:r>
+                        <a:t>0.0127</a:t>
+                      </a:r>
+                    </a:p>
+                  </a:txBody>
+                  <a:tcPr marT="27432" marB="27432">
+                    <a:solidFill>
+                      <a:srgbClr val="E4EFD8"/>
+                    </a:solidFill>
+                  </a:tcPr>
+                </a:tc>
+                <a:tc>
+                  <a:txBody>
+                    <a:bodyPr/>
+                    <a:lstStyle/>
+                    <a:p>
+                      <a:pPr algn="ctr">
+                        <a:defRPr sz="1050" b="1">
+                          <a:solidFill>
+                            <a:srgbClr val="233324"/>
+                          </a:solidFill>
+                          <a:latin typeface="Calibri"/>
+                        </a:defRPr>
+                      </a:pPr>
+                      <a:r>
+                        <a:t>0.034</a:t>
+                      </a:r>
+                    </a:p>
+                  </a:txBody>
+                  <a:tcPr marT="27432" marB="27432">
+                    <a:solidFill>
+                      <a:srgbClr val="E4EFD8"/>
+                    </a:solidFill>
+                  </a:tcPr>
+                </a:tc>
+                <a:tc>
+                  <a:txBody>
+                    <a:bodyPr/>
+                    <a:lstStyle/>
+                    <a:p>
+                      <a:pPr algn="ctr">
+                        <a:defRPr sz="1050" b="1">
+                          <a:solidFill>
+                            <a:srgbClr val="233324"/>
+                          </a:solidFill>
+                          <a:latin typeface="Calibri"/>
+                        </a:defRPr>
+                      </a:pPr>
+                      <a:r>
+                        <a:t>0.023</a:t>
+                      </a:r>
+                    </a:p>
+                  </a:txBody>
+                  <a:tcPr marT="27432" marB="27432">
+                    <a:solidFill>
+                      <a:srgbClr val="E4EFD8"/>
+                    </a:solidFill>
+                  </a:tcPr>
+                </a:tc>
+                <a:tc>
+                  <a:txBody>
+                    <a:bodyPr/>
+                    <a:lstStyle/>
+                    <a:p>
+                      <a:pPr algn="ctr">
+                        <a:defRPr sz="1050" b="1">
+                          <a:solidFill>
+                            <a:srgbClr val="233324"/>
+                          </a:solidFill>
+                          <a:latin typeface="Calibri"/>
+                        </a:defRPr>
+                      </a:pPr>
+                      <a:r>
+                        <a:t>96.2%</a:t>
+                      </a:r>
+                    </a:p>
+                  </a:txBody>
+                  <a:tcPr marT="27432" marB="27432">
+                    <a:solidFill>
+                      <a:srgbClr val="E4EFD8"/>
+                    </a:solidFill>
+                  </a:tcPr>
+                </a:tc>
+              </a:tr>
+              <a:tr h="301752">
+                <a:tc>
+                  <a:txBody>
+                    <a:bodyPr/>
+                    <a:lstStyle/>
+                    <a:p>
+                      <a:pPr algn="l">
+                        <a:defRPr sz="1050" b="0">
+                          <a:solidFill>
+                            <a:srgbClr val="233324"/>
+                          </a:solidFill>
+                          <a:latin typeface="Calibri"/>
+                        </a:defRPr>
+                      </a:pPr>
+                      <a:r>
+                        <a:t>MLP Neural Network</a:t>
+                      </a:r>
+                    </a:p>
+                  </a:txBody>
+                  <a:tcPr marT="27432" marB="27432">
+                    <a:solidFill>
+                      <a:srgbClr val="F4F7F1"/>
+                    </a:solidFill>
+                  </a:tcPr>
+                </a:tc>
+                <a:tc>
+                  <a:txBody>
+                    <a:bodyPr/>
+                    <a:lstStyle/>
+                    <a:p>
+                      <a:pPr algn="ctr">
+                        <a:defRPr sz="1050" b="0">
+                          <a:solidFill>
+                            <a:srgbClr val="233324"/>
+                          </a:solidFill>
+                          <a:latin typeface="Calibri"/>
+                        </a:defRPr>
+                      </a:pPr>
+                      <a:r>
+                        <a:t>Platt</a:t>
+                      </a:r>
+                    </a:p>
+                  </a:txBody>
+                  <a:tcPr marT="27432" marB="27432">
+                    <a:solidFill>
+                      <a:srgbClr val="F4F7F1"/>
+                    </a:solidFill>
+                  </a:tcPr>
+                </a:tc>
+                <a:tc>
+                  <a:txBody>
+                    <a:bodyPr/>
+                    <a:lstStyle/>
+                    <a:p>
+                      <a:pPr algn="ctr">
+                        <a:defRPr sz="1050" b="0">
+                          <a:solidFill>
+                            <a:srgbClr val="233324"/>
+                          </a:solidFill>
+                          <a:latin typeface="Calibri"/>
+                        </a:defRPr>
+                      </a:pPr>
+                      <a:r>
+                        <a:t>1.000</a:t>
+                      </a:r>
+                    </a:p>
+                  </a:txBody>
+                  <a:tcPr marT="27432" marB="27432">
+                    <a:solidFill>
+                      <a:srgbClr val="F4F7F1"/>
+                    </a:solidFill>
+                  </a:tcPr>
+                </a:tc>
+                <a:tc>
+                  <a:txBody>
+                    <a:bodyPr/>
+                    <a:lstStyle/>
+                    <a:p>
+                      <a:pPr algn="ctr">
+                        <a:defRPr sz="1050" b="0">
+                          <a:solidFill>
+                            <a:srgbClr val="233324"/>
+                          </a:solidFill>
+                          <a:latin typeface="Calibri"/>
+                        </a:defRPr>
+                      </a:pPr>
+                      <a:r>
+                        <a:t>0.0216</a:t>
+                      </a:r>
+                    </a:p>
+                  </a:txBody>
+                  <a:tcPr marT="27432" marB="27432">
+                    <a:solidFill>
+                      <a:srgbClr val="F4F7F1"/>
+                    </a:solidFill>
+                  </a:tcPr>
+                </a:tc>
+                <a:tc>
+                  <a:txBody>
+                    <a:bodyPr/>
+                    <a:lstStyle/>
+                    <a:p>
+                      <a:pPr algn="ctr">
+                        <a:defRPr sz="1050" b="0">
+                          <a:solidFill>
+                            <a:srgbClr val="233324"/>
+                          </a:solidFill>
+                          <a:latin typeface="Calibri"/>
+                        </a:defRPr>
+                      </a:pPr>
+                      <a:r>
+                        <a:t>0.115</a:t>
+                      </a:r>
+                    </a:p>
+                  </a:txBody>
+                  <a:tcPr marT="27432" marB="27432">
+                    <a:solidFill>
+                      <a:srgbClr val="F4F7F1"/>
+                    </a:solidFill>
+                  </a:tcPr>
+                </a:tc>
+                <a:tc>
+                  <a:txBody>
+                    <a:bodyPr/>
+                    <a:lstStyle/>
+                    <a:p>
+                      <a:pPr algn="ctr">
+                        <a:defRPr sz="1050" b="0">
+                          <a:solidFill>
+                            <a:srgbClr val="233324"/>
+                          </a:solidFill>
+                          <a:latin typeface="Calibri"/>
+                        </a:defRPr>
+                      </a:pPr>
+                      <a:r>
+                        <a:t>0.099</a:t>
+                      </a:r>
+                    </a:p>
+                  </a:txBody>
+                  <a:tcPr marT="27432" marB="27432">
+                    <a:solidFill>
+                      <a:srgbClr val="F4F7F1"/>
+                    </a:solidFill>
+                  </a:tcPr>
+                </a:tc>
+                <a:tc>
+                  <a:txBody>
+                    <a:bodyPr/>
+                    <a:lstStyle/>
+                    <a:p>
+                      <a:pPr algn="ctr">
+                        <a:defRPr sz="1050" b="0">
+                          <a:solidFill>
+                            <a:srgbClr val="233324"/>
+                          </a:solidFill>
+                          <a:latin typeface="Calibri"/>
+                        </a:defRPr>
+                      </a:pPr>
+                      <a:r>
+                        <a:t>96.2%</a:t>
+                      </a:r>
+                    </a:p>
+                  </a:txBody>
+                  <a:tcPr marT="27432" marB="27432">
+                    <a:solidFill>
+                      <a:srgbClr val="F4F7F1"/>
+                    </a:solidFill>
+                  </a:tcPr>
+                </a:tc>
+              </a:tr>
+              <a:tr h="301752">
+                <a:tc>
+                  <a:txBody>
+                    <a:bodyPr/>
+                    <a:lstStyle/>
+                    <a:p>
+                      <a:pPr algn="l">
+                        <a:defRPr sz="1050" b="0">
+                          <a:solidFill>
+                            <a:srgbClr val="233324"/>
+                          </a:solidFill>
+                          <a:latin typeface="Calibri"/>
+                        </a:defRPr>
+                      </a:pPr>
+                      <a:r>
+                        <a:t>MLP Neural Network</a:t>
+                      </a:r>
+                    </a:p>
+                  </a:txBody>
+                  <a:tcPr marT="27432" marB="27432">
+                    <a:solidFill>
+                      <a:srgbClr val="FFFFFF"/>
+                    </a:solidFill>
+                  </a:tcPr>
+                </a:tc>
+                <a:tc>
+                  <a:txBody>
+                    <a:bodyPr/>
+                    <a:lstStyle/>
+                    <a:p>
+                      <a:pPr algn="ctr">
+                        <a:defRPr sz="1050" b="0">
+                          <a:solidFill>
+                            <a:srgbClr val="233324"/>
+                          </a:solidFill>
+                          <a:latin typeface="Calibri"/>
+                        </a:defRPr>
+                      </a:pPr>
+                      <a:r>
+                        <a:t>Isotonic</a:t>
+                      </a:r>
+                    </a:p>
+                  </a:txBody>
+                  <a:tcPr marT="27432" marB="27432">
+                    <a:solidFill>
+                      <a:srgbClr val="FFFFFF"/>
+                    </a:solidFill>
+                  </a:tcPr>
+                </a:tc>
+                <a:tc>
+                  <a:txBody>
+                    <a:bodyPr/>
+                    <a:lstStyle/>
+                    <a:p>
+                      <a:pPr algn="ctr">
+                        <a:defRPr sz="1050" b="0">
+                          <a:solidFill>
+                            <a:srgbClr val="233324"/>
+                          </a:solidFill>
+                          <a:latin typeface="Calibri"/>
+                        </a:defRPr>
+                      </a:pPr>
+                      <a:r>
+                        <a:t>1.000</a:t>
+                      </a:r>
+                    </a:p>
+                  </a:txBody>
+                  <a:tcPr marT="27432" marB="27432">
+                    <a:solidFill>
+                      <a:srgbClr val="FFFFFF"/>
+                    </a:solidFill>
+                  </a:tcPr>
+                </a:tc>
+                <a:tc>
+                  <a:txBody>
+                    <a:bodyPr/>
+                    <a:lstStyle/>
+                    <a:p>
+                      <a:pPr algn="ctr">
+                        <a:defRPr sz="1050" b="0">
+                          <a:solidFill>
+                            <a:srgbClr val="233324"/>
+                          </a:solidFill>
+                          <a:latin typeface="Calibri"/>
+                        </a:defRPr>
+                      </a:pPr>
+                      <a:r>
+                        <a:t>0.0138</a:t>
+                      </a:r>
+                    </a:p>
+                  </a:txBody>
+                  <a:tcPr marT="27432" marB="27432">
+                    <a:solidFill>
+                      <a:srgbClr val="FFFFFF"/>
+                    </a:solidFill>
+                  </a:tcPr>
+                </a:tc>
+                <a:tc>
+                  <a:txBody>
+                    <a:bodyPr/>
+                    <a:lstStyle/>
+                    <a:p>
+                      <a:pPr algn="ctr">
+                        <a:defRPr sz="1050" b="0">
+                          <a:solidFill>
+                            <a:srgbClr val="233324"/>
+                          </a:solidFill>
+                          <a:latin typeface="Calibri"/>
+                        </a:defRPr>
+                      </a:pPr>
+                      <a:r>
+                        <a:t>0.036</a:t>
+                      </a:r>
+                    </a:p>
+                  </a:txBody>
+                  <a:tcPr marT="27432" marB="27432">
+                    <a:solidFill>
+                      <a:srgbClr val="FFFFFF"/>
+                    </a:solidFill>
+                  </a:tcPr>
+                </a:tc>
+                <a:tc>
+                  <a:txBody>
+                    <a:bodyPr/>
+                    <a:lstStyle/>
+                    <a:p>
+                      <a:pPr algn="ctr">
+                        <a:defRPr sz="1050" b="0">
+                          <a:solidFill>
+                            <a:srgbClr val="233324"/>
+                          </a:solidFill>
+                          <a:latin typeface="Calibri"/>
+                        </a:defRPr>
+                      </a:pPr>
+                      <a:r>
+                        <a:t>0.023</a:t>
+                      </a:r>
+                    </a:p>
+                  </a:txBody>
+                  <a:tcPr marT="27432" marB="27432">
+                    <a:solidFill>
+                      <a:srgbClr val="FFFFFF"/>
+                    </a:solidFill>
+                  </a:tcPr>
+                </a:tc>
+                <a:tc>
+                  <a:txBody>
+                    <a:bodyPr/>
+                    <a:lstStyle/>
+                    <a:p>
+                      <a:pPr algn="ctr">
+                        <a:defRPr sz="1050" b="0">
+                          <a:solidFill>
+                            <a:srgbClr val="233324"/>
+                          </a:solidFill>
+                          <a:latin typeface="Calibri"/>
+                        </a:defRPr>
+                      </a:pPr>
+                      <a:r>
+                        <a:t>96.2%</a:t>
+                      </a:r>
+                    </a:p>
+                  </a:txBody>
+                  <a:tcPr marT="27432" marB="27432">
+                    <a:solidFill>
+                      <a:srgbClr val="FFFFFF"/>
+                    </a:solidFill>
+                  </a:tcPr>
+                </a:tc>
+              </a:tr>
+            </a:tbl>
+          </a:graphicData>
+        </a:graphic>
+      </p:graphicFrame>
+      <p:sp>
+        <p:nvSpPr>
+          <p:cNvPr id="8" name="TextBox 7"/>
+          <p:cNvSpPr txBox="1"/>
+          <p:nvPr/>
+        </p:nvSpPr>
+        <p:spPr>
+          <a:xfrm>
+            <a:off x="731520" y="5806440"/>
+            <a:ext cx="10698480" cy="548640"/>
           </a:xfrm>
           <a:prstGeom prst="rect">
             <a:avLst/>
@@ -8301,42 +11131,238 @@
           <a:lstStyle/>
           <a:p>
             <a:pPr>
-              <a:defRPr sz="2600" b="1">
-                <a:solidFill>
-                  <a:srgbClr val="FFFFFF"/>
+              <a:defRPr sz="1000">
+                <a:solidFill>
+                  <a:srgbClr val="5B6B5C"/>
+                </a:solidFill>
+                <a:latin typeface="Calibri"/>
+              </a:defRPr>
+            </a:pPr>
+            <a:r>
+              <a:t>Akurasi dihitung pada threshold 0.5. Log Loss Isotonic tinggi karena kalibrator menghasilkan probabilitas tepat 0/1 pada sebagian task; ini wajar untuk kalibrator non-parametrik yang dilatih pada ±20 sampel per fold.</a:t>
+            </a:r>
+          </a:p>
+        </p:txBody>
+      </p:sp>
+    </p:spTree>
+  </p:cSld>
+  <p:clrMapOvr>
+    <a:masterClrMapping/>
+  </p:clrMapOvr>
+</p:sld>
+</file>
+
+<file path=ppt/slides/slide9.xml><?xml version="1.0" encoding="utf-8"?>
+<p:sld xmlns:a="http://schemas.openxmlformats.org/drawingml/2006/main" xmlns:p="http://schemas.openxmlformats.org/presentationml/2006/main" xmlns:r="http://schemas.openxmlformats.org/officeDocument/2006/relationships">
+  <p:cSld>
+    <p:spTree>
+      <p:nvGrpSpPr>
+        <p:cNvPr id="1" name=""/>
+        <p:cNvGrpSpPr/>
+        <p:nvPr/>
+      </p:nvGrpSpPr>
+      <p:grpSpPr/>
+      <p:sp>
+        <p:nvSpPr>
+          <p:cNvPr id="2" name="TextBox 1"/>
+          <p:cNvSpPr txBox="1"/>
+          <p:nvPr/>
+        </p:nvSpPr>
+        <p:spPr>
+          <a:xfrm>
+            <a:off x="731520" y="411480"/>
+            <a:ext cx="10058400" cy="320040"/>
+          </a:xfrm>
+          <a:prstGeom prst="rect">
+            <a:avLst/>
+          </a:prstGeom>
+          <a:noFill/>
+        </p:spPr>
+        <p:txBody>
+          <a:bodyPr wrap="square" lIns="0" tIns="0" rIns="0" bIns="0">
+            <a:spAutoFit/>
+          </a:bodyPr>
+          <a:lstStyle/>
+          <a:p>
+            <a:pPr>
+              <a:defRPr sz="1000" b="1">
+                <a:solidFill>
+                  <a:srgbClr val="E8A33D"/>
+                </a:solidFill>
+                <a:latin typeface="Calibri"/>
+              </a:defRPr>
+            </a:pPr>
+            <a:r>
+              <a:t>TEMUAN KUNCI</a:t>
+            </a:r>
+          </a:p>
+        </p:txBody>
+      </p:sp>
+      <p:sp>
+        <p:nvSpPr>
+          <p:cNvPr id="3" name="TextBox 2"/>
+          <p:cNvSpPr txBox="1"/>
+          <p:nvPr/>
+        </p:nvSpPr>
+        <p:spPr>
+          <a:xfrm>
+            <a:off x="731520" y="685800"/>
+            <a:ext cx="10515600" cy="594360"/>
+          </a:xfrm>
+          <a:prstGeom prst="rect">
+            <a:avLst/>
+          </a:prstGeom>
+          <a:noFill/>
+        </p:spPr>
+        <p:txBody>
+          <a:bodyPr wrap="square" lIns="0" tIns="0" rIns="0" bIns="0">
+            <a:spAutoFit/>
+          </a:bodyPr>
+          <a:lstStyle/>
+          <a:p>
+            <a:pPr>
+              <a:defRPr sz="2200" b="1">
+                <a:solidFill>
+                  <a:srgbClr val="1E4220"/>
                 </a:solidFill>
                 <a:latin typeface="Cambria"/>
               </a:defRPr>
             </a:pPr>
             <a:r>
-              <a:t>Capaian Pertemuan 4 Siap 100%:</a:t>
-            </a:r>
-            <a:br/>
-            <a:r>
-              <a:t>Transisi Mulus Menuju Eksekusi &amp; Hasil (Pertemuan 5)</a:t>
-            </a:r>
-          </a:p>
-        </p:txBody>
-      </p:sp>
-      <p:sp>
-        <p:nvSpPr>
-          <p:cNvPr id="4" name="Rounded Rectangle 3"/>
+              <a:t>Apa yang Ditunjukkan Hasil Eksperimen?</a:t>
+            </a:r>
+          </a:p>
+        </p:txBody>
+      </p:sp>
+      <p:sp>
+        <p:nvSpPr>
+          <p:cNvPr id="4" name="TextBox 3"/>
+          <p:cNvSpPr txBox="1"/>
+          <p:nvPr/>
+        </p:nvSpPr>
+        <p:spPr>
+          <a:xfrm>
+            <a:off x="731520" y="1234440"/>
+            <a:ext cx="10515600" cy="320040"/>
+          </a:xfrm>
+          <a:prstGeom prst="rect">
+            <a:avLst/>
+          </a:prstGeom>
+          <a:noFill/>
+        </p:spPr>
+        <p:txBody>
+          <a:bodyPr wrap="square" lIns="0" tIns="0" rIns="0" bIns="0">
+            <a:spAutoFit/>
+          </a:bodyPr>
+          <a:lstStyle/>
+          <a:p>
+            <a:pPr>
+              <a:defRPr sz="1150">
+                <a:solidFill>
+                  <a:srgbClr val="5B6B5C"/>
+                </a:solidFill>
+                <a:latin typeface="Calibri"/>
+              </a:defRPr>
+            </a:pPr>
+            <a:r>
+              <a:t>Seluruh angka dibaca langsung dari keluaran experiment_pipeline.py.</a:t>
+            </a:r>
+          </a:p>
+        </p:txBody>
+      </p:sp>
+      <p:sp>
+        <p:nvSpPr>
+          <p:cNvPr id="5" name="TextBox 4"/>
+          <p:cNvSpPr txBox="1"/>
+          <p:nvPr/>
+        </p:nvSpPr>
+        <p:spPr>
+          <a:xfrm>
+            <a:off x="731520" y="6492240"/>
+            <a:ext cx="7315200" cy="274320"/>
+          </a:xfrm>
+          <a:prstGeom prst="rect">
+            <a:avLst/>
+          </a:prstGeom>
+          <a:noFill/>
+        </p:spPr>
+        <p:txBody>
+          <a:bodyPr wrap="square" lIns="0" tIns="0" rIns="0" bIns="0">
+            <a:spAutoFit/>
+          </a:bodyPr>
+          <a:lstStyle/>
+          <a:p>
+            <a:pPr>
+              <a:defRPr sz="900">
+                <a:solidFill>
+                  <a:srgbClr val="5B6B5C"/>
+                </a:solidFill>
+                <a:latin typeface="Calibri"/>
+              </a:defRPr>
+            </a:pPr>
+            <a:r>
+              <a:t>PRE-02 — Prediksi Probabilitas Keterlambatan Proyek Multi Sumber Daya Terbatas</a:t>
+            </a:r>
+          </a:p>
+        </p:txBody>
+      </p:sp>
+      <p:sp>
+        <p:nvSpPr>
+          <p:cNvPr id="6" name="TextBox 5"/>
+          <p:cNvSpPr txBox="1"/>
+          <p:nvPr/>
+        </p:nvSpPr>
+        <p:spPr>
+          <a:xfrm>
+            <a:off x="10972800" y="6492240"/>
+            <a:ext cx="457200" cy="274320"/>
+          </a:xfrm>
+          <a:prstGeom prst="rect">
+            <a:avLst/>
+          </a:prstGeom>
+          <a:noFill/>
+        </p:spPr>
+        <p:txBody>
+          <a:bodyPr wrap="square" lIns="0" tIns="0" rIns="0" bIns="0">
+            <a:spAutoFit/>
+          </a:bodyPr>
+          <a:lstStyle/>
+          <a:p>
+            <a:pPr>
+              <a:defRPr sz="900">
+                <a:solidFill>
+                  <a:srgbClr val="5B6B5C"/>
+                </a:solidFill>
+                <a:latin typeface="Calibri"/>
+              </a:defRPr>
+            </a:pPr>
+            <a:r>
+              <a:t>9</a:t>
+            </a:r>
+          </a:p>
+        </p:txBody>
+      </p:sp>
+      <p:sp>
+        <p:nvSpPr>
+          <p:cNvPr id="7" name="Rounded Rectangle 6"/>
           <p:cNvSpPr/>
           <p:nvPr/>
         </p:nvSpPr>
         <p:spPr>
           <a:xfrm>
-            <a:off x="731520" y="3017520"/>
-            <a:ext cx="3383280" cy="2926080"/>
+            <a:off x="731520" y="1783080"/>
+            <a:ext cx="5760720" cy="3246120"/>
           </a:xfrm>
           <a:prstGeom prst="roundRect">
             <a:avLst/>
           </a:prstGeom>
           <a:solidFill>
-            <a:srgbClr val="2C5F2D"/>
+            <a:srgbClr val="F4F7F1"/>
           </a:solidFill>
           <a:ln>
-            <a:noFill/>
+            <a:solidFill>
+              <a:srgbClr val="D0DECC"/>
+            </a:solidFill>
           </a:ln>
         </p:spPr>
         <p:style>
@@ -8363,14 +11389,14 @@
       </p:sp>
       <p:sp>
         <p:nvSpPr>
-          <p:cNvPr id="5" name="TextBox 4"/>
-          <p:cNvSpPr txBox="1"/>
-          <p:nvPr/>
-        </p:nvSpPr>
-        <p:spPr>
-          <a:xfrm>
-            <a:off x="1005840" y="3383280"/>
-            <a:ext cx="2834640" cy="548640"/>
+          <p:cNvPr id="8" name="TextBox 7"/>
+          <p:cNvSpPr txBox="1"/>
+          <p:nvPr/>
+        </p:nvSpPr>
+        <p:spPr>
+          <a:xfrm>
+            <a:off x="1005840" y="1965960"/>
+            <a:ext cx="5303520" cy="2926080"/>
           </a:xfrm>
           <a:prstGeom prst="rect">
             <a:avLst/>
@@ -8384,29 +11410,190 @@
           <a:lstStyle/>
           <a:p>
             <a:pPr>
-              <a:defRPr sz="1500" b="1">
-                <a:solidFill>
-                  <a:srgbClr val="E8A33D"/>
-                </a:solidFill>
-                <a:latin typeface="Cambria"/>
-              </a:defRPr>
-            </a:pPr>
-            <a:r>
-              <a:t>1. Flowchart &amp; Skenario</a:t>
-            </a:r>
-          </a:p>
-        </p:txBody>
-      </p:sp>
-      <p:sp>
-        <p:nvSpPr>
-          <p:cNvPr id="6" name="TextBox 5"/>
-          <p:cNvSpPr txBox="1"/>
-          <p:nvPr/>
-        </p:nvSpPr>
-        <p:spPr>
-          <a:xfrm>
-            <a:off x="1005840" y="4023360"/>
-            <a:ext cx="2834640" cy="1645920"/>
+              <a:spcAft>
+                <a:spcPts val="700"/>
+              </a:spcAft>
+            </a:pPr>
+            <a:r>
+              <a:rPr sz="1000" b="1">
+                <a:solidFill>
+                  <a:srgbClr val="2C5F2D"/>
+                </a:solidFill>
+                <a:latin typeface="Calibri"/>
+              </a:rPr>
+              <a:t>DISKRIMINASI  </a:t>
+            </a:r>
+            <a:r>
+              <a:rPr sz="1200">
+                <a:solidFill>
+                  <a:srgbClr val="233324"/>
+                </a:solidFill>
+                <a:latin typeface="Calibri"/>
+              </a:rPr>
+              <a:t>ROC-AUC tertinggi 1.000 dicapai Logistic Regression (Baseline) dan MLP Neural Network.</a:t>
+            </a:r>
+          </a:p>
+          <a:p>
+            <a:pPr>
+              <a:spcAft>
+                <a:spcPts val="700"/>
+              </a:spcAft>
+            </a:pPr>
+            <a:r>
+              <a:rPr sz="1000" b="1">
+                <a:solidFill>
+                  <a:srgbClr val="2C5F2D"/>
+                </a:solidFill>
+                <a:latin typeface="Calibri"/>
+              </a:rPr>
+              <a:t>MODEL REKOMENDASI  </a:t>
+            </a:r>
+            <a:r>
+              <a:rPr sz="1200">
+                <a:solidFill>
+                  <a:srgbClr val="233324"/>
+                </a:solidFill>
+                <a:latin typeface="Calibri"/>
+              </a:rPr>
+              <a:t>MLP Neural Network (tanpa kalibrasi): Brier 0.0127, ECE 0.023.</a:t>
+            </a:r>
+          </a:p>
+          <a:p>
+            <a:pPr>
+              <a:spcAft>
+                <a:spcPts val="700"/>
+              </a:spcAft>
+            </a:pPr>
+            <a:r>
+              <a:rPr sz="1000" b="1">
+                <a:solidFill>
+                  <a:srgbClr val="2C5F2D"/>
+                </a:solidFill>
+                <a:latin typeface="Calibri"/>
+              </a:rPr>
+              <a:t>EFEK KALIBRASI  </a:t>
+            </a:r>
+            <a:r>
+              <a:rPr sz="1200">
+                <a:solidFill>
+                  <a:srgbClr val="233324"/>
+                </a:solidFill>
+                <a:latin typeface="Calibri"/>
+              </a:rPr>
+              <a:t>Kalibrasi menurunkan Brier Score pada Gradient Boosting; model lain tidak membaik.</a:t>
+            </a:r>
+          </a:p>
+          <a:p>
+            <a:pPr>
+              <a:spcAft>
+                <a:spcPts val="700"/>
+              </a:spcAft>
+            </a:pPr>
+            <a:r>
+              <a:rPr sz="1000" b="1">
+                <a:solidFill>
+                  <a:srgbClr val="2C5F2D"/>
+                </a:solidFill>
+                <a:latin typeface="Calibri"/>
+              </a:rPr>
+              <a:t>FITUR DOMINAN  </a:t>
+            </a:r>
+            <a:r>
+              <a:rPr sz="1200">
+                <a:solidFill>
+                  <a:srgbClr val="233324"/>
+                </a:solidFill>
+                <a:latin typeface="Calibri"/>
+              </a:rPr>
+              <a:t>SPI_Value (0.310) dan Risk_Score (0.307) menurut MDI Random Forest.</a:t>
+            </a:r>
+          </a:p>
+          <a:p>
+            <a:pPr>
+              <a:spcAft>
+                <a:spcPts val="700"/>
+              </a:spcAft>
+            </a:pPr>
+            <a:r>
+              <a:rPr sz="1000" b="1">
+                <a:solidFill>
+                  <a:srgbClr val="2C5F2D"/>
+                </a:solidFill>
+                <a:latin typeface="Calibri"/>
+              </a:rPr>
+              <a:t>YOUDEN J  </a:t>
+            </a:r>
+            <a:r>
+              <a:rPr sz="1200">
+                <a:solidFill>
+                  <a:srgbClr val="233324"/>
+                </a:solidFill>
+                <a:latin typeface="Calibri"/>
+              </a:rPr>
+              <a:t>θ* = 0.779 (Sensitivity 1.00, Specificity 1.00).</a:t>
+            </a:r>
+          </a:p>
+          <a:p>
+            <a:pPr>
+              <a:spcAft>
+                <a:spcPts val="700"/>
+              </a:spcAft>
+            </a:pPr>
+            <a:r>
+              <a:rPr sz="1000" b="1">
+                <a:solidFill>
+                  <a:srgbClr val="2C5F2D"/>
+                </a:solidFill>
+                <a:latin typeface="Calibri"/>
+              </a:rPr>
+              <a:t>EWS  </a:t>
+            </a:r>
+            <a:r>
+              <a:rPr sz="1200">
+                <a:solidFill>
+                  <a:srgbClr val="233324"/>
+                </a:solidFill>
+                <a:latin typeface="Calibri"/>
+              </a:rPr>
+              <a:t>Zona Merah menangkap 16/16 task terlambat dengan 0 alarm palsu; 0 task terlambat lolos ke zona Hijau.</a:t>
+            </a:r>
+          </a:p>
+        </p:txBody>
+      </p:sp>
+      <p:pic>
+        <p:nvPicPr>
+          <p:cNvPr id="9" name="Picture 8" descr="feature_importance_comparison.png"/>
+          <p:cNvPicPr>
+            <a:picLocks noChangeAspect="1"/>
+          </p:cNvPicPr>
+          <p:nvPr/>
+        </p:nvPicPr>
+        <p:blipFill>
+          <a:blip r:embed="rId2"/>
+          <a:stretch>
+            <a:fillRect/>
+          </a:stretch>
+        </p:blipFill>
+        <p:spPr>
+          <a:xfrm>
+            <a:off x="6720840" y="1920240"/>
+            <a:ext cx="4754880" cy="2462972"/>
+          </a:xfrm>
+          <a:prstGeom prst="rect">
+            <a:avLst/>
+          </a:prstGeom>
+        </p:spPr>
+      </p:pic>
+      <p:sp>
+        <p:nvSpPr>
+          <p:cNvPr id="10" name="TextBox 9"/>
+          <p:cNvSpPr txBox="1"/>
+          <p:nvPr/>
+        </p:nvSpPr>
+        <p:spPr>
+          <a:xfrm>
+            <a:off x="6720840" y="4754880"/>
+            <a:ext cx="4754880" cy="1463040"/>
           </a:xfrm>
           <a:prstGeom prst="rect">
             <a:avLst/>
@@ -8420,245 +11607,15 @@
           <a:lstStyle/>
           <a:p>
             <a:pPr>
-              <a:defRPr sz="1200">
-                <a:solidFill>
-                  <a:srgbClr val="E4EFD8"/>
+              <a:defRPr sz="1050" i="1">
+                <a:solidFill>
+                  <a:srgbClr val="5B6B5C"/>
                 </a:solidFill>
                 <a:latin typeface="Calibri"/>
               </a:defRPr>
             </a:pPr>
             <a:r>
-              <a:t>Dokumen alur pemodelan CRISP-DM dan 5 skenario algoritma telah dibakukan secara metodologis.</a:t>
-            </a:r>
-          </a:p>
-        </p:txBody>
-      </p:sp>
-      <p:sp>
-        <p:nvSpPr>
-          <p:cNvPr id="7" name="Rounded Rectangle 6"/>
-          <p:cNvSpPr/>
-          <p:nvPr/>
-        </p:nvSpPr>
-        <p:spPr>
-          <a:xfrm>
-            <a:off x="4389120" y="3017520"/>
-            <a:ext cx="3383280" cy="2926080"/>
-          </a:xfrm>
-          <a:prstGeom prst="roundRect">
-            <a:avLst/>
-          </a:prstGeom>
-          <a:solidFill>
-            <a:srgbClr val="2C5F2D"/>
-          </a:solidFill>
-          <a:ln>
-            <a:noFill/>
-          </a:ln>
-        </p:spPr>
-        <p:style>
-          <a:lnRef idx="1">
-            <a:schemeClr val="accent1"/>
-          </a:lnRef>
-          <a:fillRef idx="3">
-            <a:schemeClr val="accent1"/>
-          </a:fillRef>
-          <a:effectRef idx="2">
-            <a:schemeClr val="accent1"/>
-          </a:effectRef>
-          <a:fontRef idx="minor">
-            <a:schemeClr val="lt1"/>
-          </a:fontRef>
-        </p:style>
-        <p:txBody>
-          <a:bodyPr rtlCol="0" anchor="ctr"/>
-          <a:lstStyle/>
-          <a:p>
-            <a:pPr algn="ctr"/>
-          </a:p>
-        </p:txBody>
-      </p:sp>
-      <p:sp>
-        <p:nvSpPr>
-          <p:cNvPr id="8" name="TextBox 7"/>
-          <p:cNvSpPr txBox="1"/>
-          <p:nvPr/>
-        </p:nvSpPr>
-        <p:spPr>
-          <a:xfrm>
-            <a:off x="4663440" y="3383280"/>
-            <a:ext cx="2834640" cy="548640"/>
-          </a:xfrm>
-          <a:prstGeom prst="rect">
-            <a:avLst/>
-          </a:prstGeom>
-          <a:noFill/>
-        </p:spPr>
-        <p:txBody>
-          <a:bodyPr wrap="square">
-            <a:spAutoFit/>
-          </a:bodyPr>
-          <a:lstStyle/>
-          <a:p>
-            <a:pPr>
-              <a:defRPr sz="1500" b="1">
-                <a:solidFill>
-                  <a:srgbClr val="E8A33D"/>
-                </a:solidFill>
-                <a:latin typeface="Cambria"/>
-              </a:defRPr>
-            </a:pPr>
-            <a:r>
-              <a:t>2. Script Python ML Pipeline</a:t>
-            </a:r>
-          </a:p>
-        </p:txBody>
-      </p:sp>
-      <p:sp>
-        <p:nvSpPr>
-          <p:cNvPr id="9" name="TextBox 8"/>
-          <p:cNvSpPr txBox="1"/>
-          <p:nvPr/>
-        </p:nvSpPr>
-        <p:spPr>
-          <a:xfrm>
-            <a:off x="4663440" y="4023360"/>
-            <a:ext cx="2834640" cy="1645920"/>
-          </a:xfrm>
-          <a:prstGeom prst="rect">
-            <a:avLst/>
-          </a:prstGeom>
-          <a:noFill/>
-        </p:spPr>
-        <p:txBody>
-          <a:bodyPr wrap="square">
-            <a:spAutoFit/>
-          </a:bodyPr>
-          <a:lstStyle/>
-          <a:p>
-            <a:pPr>
-              <a:defRPr sz="1200">
-                <a:solidFill>
-                  <a:srgbClr val="E4EFD8"/>
-                </a:solidFill>
-                <a:latin typeface="Calibri"/>
-              </a:defRPr>
-            </a:pPr>
-            <a:r>
-              <a:t>Script 'experiment_pipeline.py' siap mengeksekusi 4 model, kalibrasi, plotting kurva ROC, dan ECE.</a:t>
-            </a:r>
-          </a:p>
-        </p:txBody>
-      </p:sp>
-      <p:sp>
-        <p:nvSpPr>
-          <p:cNvPr id="10" name="Rounded Rectangle 9"/>
-          <p:cNvSpPr/>
-          <p:nvPr/>
-        </p:nvSpPr>
-        <p:spPr>
-          <a:xfrm>
-            <a:off x="8046720" y="3017520"/>
-            <a:ext cx="3383280" cy="2926080"/>
-          </a:xfrm>
-          <a:prstGeom prst="roundRect">
-            <a:avLst/>
-          </a:prstGeom>
-          <a:solidFill>
-            <a:srgbClr val="2C5F2D"/>
-          </a:solidFill>
-          <a:ln>
-            <a:noFill/>
-          </a:ln>
-        </p:spPr>
-        <p:style>
-          <a:lnRef idx="1">
-            <a:schemeClr val="accent1"/>
-          </a:lnRef>
-          <a:fillRef idx="3">
-            <a:schemeClr val="accent1"/>
-          </a:fillRef>
-          <a:effectRef idx="2">
-            <a:schemeClr val="accent1"/>
-          </a:effectRef>
-          <a:fontRef idx="minor">
-            <a:schemeClr val="lt1"/>
-          </a:fontRef>
-        </p:style>
-        <p:txBody>
-          <a:bodyPr rtlCol="0" anchor="ctr"/>
-          <a:lstStyle/>
-          <a:p>
-            <a:pPr algn="ctr"/>
-          </a:p>
-        </p:txBody>
-      </p:sp>
-      <p:sp>
-        <p:nvSpPr>
-          <p:cNvPr id="11" name="TextBox 10"/>
-          <p:cNvSpPr txBox="1"/>
-          <p:nvPr/>
-        </p:nvSpPr>
-        <p:spPr>
-          <a:xfrm>
-            <a:off x="8321040" y="3383280"/>
-            <a:ext cx="2834640" cy="548640"/>
-          </a:xfrm>
-          <a:prstGeom prst="rect">
-            <a:avLst/>
-          </a:prstGeom>
-          <a:noFill/>
-        </p:spPr>
-        <p:txBody>
-          <a:bodyPr wrap="square">
-            <a:spAutoFit/>
-          </a:bodyPr>
-          <a:lstStyle/>
-          <a:p>
-            <a:pPr>
-              <a:defRPr sz="1500" b="1">
-                <a:solidFill>
-                  <a:srgbClr val="E8A33D"/>
-                </a:solidFill>
-                <a:latin typeface="Cambria"/>
-              </a:defRPr>
-            </a:pPr>
-            <a:r>
-              <a:t>3. Draft Naskah Bab 3</a:t>
-            </a:r>
-          </a:p>
-        </p:txBody>
-      </p:sp>
-      <p:sp>
-        <p:nvSpPr>
-          <p:cNvPr id="12" name="TextBox 11"/>
-          <p:cNvSpPr txBox="1"/>
-          <p:nvPr/>
-        </p:nvSpPr>
-        <p:spPr>
-          <a:xfrm>
-            <a:off x="8321040" y="4023360"/>
-            <a:ext cx="2834640" cy="1645920"/>
-          </a:xfrm>
-          <a:prstGeom prst="rect">
-            <a:avLst/>
-          </a:prstGeom>
-          <a:noFill/>
-        </p:spPr>
-        <p:txBody>
-          <a:bodyPr wrap="square">
-            <a:spAutoFit/>
-          </a:bodyPr>
-          <a:lstStyle/>
-          <a:p>
-            <a:pPr>
-              <a:defRPr sz="1200">
-                <a:solidFill>
-                  <a:srgbClr val="E4EFD8"/>
-                </a:solidFill>
-                <a:latin typeface="Calibri"/>
-              </a:defRPr>
-            </a:pPr>
-            <a:r>
-              <a:t>Bab III Metodologi Penelitian telah ditulis lengkap mengikuti standar publikasi jurnal bereputasi.</a:t>
+              <a:t>Catatan: fitur multi sumber daya (Resource_Utilization_Rate, Predecessor_Count) bukan prediktor dominan pada data ini, sehingga hipotesis kendala multi sumber daya perlu dikaji ulang pada Bab IV.</a:t>
             </a:r>
           </a:p>
         </p:txBody>

</xml_diff>